<commit_message>
0628 + roadmap skill update including Gantt chart and schedule
</commit_message>
<xml_diff>
--- a/docs/roadmap-pptx/Korean_Bible_App_Roadmap_및_작업제안_2026-06-28.pptx
+++ b/docs/roadmap-pptx/Korean_Bible_App_Roadmap_및_작업제안_2026-06-28.pptx
@@ -15,6 +15,7 @@
     <p:sldId id="263" r:id="rId14"/>
     <p:sldId id="264" r:id="rId15"/>
     <p:sldId id="265" r:id="rId16"/>
+    <p:sldId id="266" r:id="rId17"/>
   </p:sldIdLst>
   <p:sldSz cx="9144000" cy="5143500" type="screen4x3"/>
   <p:notesSz cx="6858000" cy="9144000"/>
@@ -3367,6 +3368,830 @@
             <a:avLst/>
           </a:prstGeom>
           <a:solidFill>
+            <a:srgbClr val="D97706"/>
+          </a:solidFill>
+          <a:ln>
+            <a:noFill/>
+          </a:ln>
+        </p:spPr>
+        <p:style>
+          <a:lnRef idx="1">
+            <a:schemeClr val="accent1"/>
+          </a:lnRef>
+          <a:fillRef idx="3">
+            <a:schemeClr val="accent1"/>
+          </a:fillRef>
+          <a:effectRef idx="2">
+            <a:schemeClr val="accent1"/>
+          </a:effectRef>
+          <a:fontRef idx="minor">
+            <a:schemeClr val="lt1"/>
+          </a:fontRef>
+        </p:style>
+        <p:txBody>
+          <a:bodyPr rtlCol="0" anchor="ctr"/>
+          <a:lstStyle/>
+          <a:p>
+            <a:pPr algn="ctr"/>
+          </a:p>
+        </p:txBody>
+      </p:sp>
+      <p:sp>
+        <p:nvSpPr>
+          <p:cNvPr id="4" name="TextBox 3"/>
+          <p:cNvSpPr txBox="1"/>
+          <p:nvPr/>
+        </p:nvSpPr>
+        <p:spPr>
+          <a:xfrm>
+            <a:off x="457200" y="228600"/>
+            <a:ext cx="8229600" cy="457200"/>
+          </a:xfrm>
+          <a:prstGeom prst="rect">
+            <a:avLst/>
+          </a:prstGeom>
+          <a:noFill/>
+        </p:spPr>
+        <p:txBody>
+          <a:bodyPr wrap="square">
+            <a:spAutoFit/>
+          </a:bodyPr>
+          <a:lstStyle/>
+          <a:p>
+            <a:pPr algn="l">
+              <a:defRPr sz="2400" b="1">
+                <a:solidFill>
+                  <a:srgbClr val="1E3A5F"/>
+                </a:solidFill>
+                <a:latin typeface="Malgun Gothic"/>
+              </a:defRPr>
+            </a:pPr>
+            <a:r>
+              <a:t>우선순위 작업 순서 (요약)</a:t>
+            </a:r>
+          </a:p>
+        </p:txBody>
+      </p:sp>
+      <p:sp>
+        <p:nvSpPr>
+          <p:cNvPr id="5" name="Rounded Rectangle 4"/>
+          <p:cNvSpPr/>
+          <p:nvPr/>
+        </p:nvSpPr>
+        <p:spPr>
+          <a:xfrm>
+            <a:off x="457200" y="868680"/>
+            <a:ext cx="8229600" cy="384048"/>
+          </a:xfrm>
+          <a:prstGeom prst="roundRect">
+            <a:avLst/>
+          </a:prstGeom>
+          <a:solidFill>
+            <a:srgbClr val="FFFFFF"/>
+          </a:solidFill>
+          <a:ln>
+            <a:solidFill>
+              <a:srgbClr val="E2E8F0"/>
+            </a:solidFill>
+          </a:ln>
+        </p:spPr>
+        <p:style>
+          <a:lnRef idx="1">
+            <a:schemeClr val="accent1"/>
+          </a:lnRef>
+          <a:fillRef idx="3">
+            <a:schemeClr val="accent1"/>
+          </a:fillRef>
+          <a:effectRef idx="2">
+            <a:schemeClr val="accent1"/>
+          </a:effectRef>
+          <a:fontRef idx="minor">
+            <a:schemeClr val="lt1"/>
+          </a:fontRef>
+        </p:style>
+        <p:txBody>
+          <a:bodyPr rtlCol="0" anchor="ctr"/>
+          <a:lstStyle/>
+          <a:p>
+            <a:pPr algn="ctr"/>
+          </a:p>
+        </p:txBody>
+      </p:sp>
+      <p:sp>
+        <p:nvSpPr>
+          <p:cNvPr id="6" name="TextBox 5"/>
+          <p:cNvSpPr txBox="1"/>
+          <p:nvPr/>
+        </p:nvSpPr>
+        <p:spPr>
+          <a:xfrm>
+            <a:off x="640080" y="914400"/>
+            <a:ext cx="7863840" cy="320040"/>
+          </a:xfrm>
+          <a:prstGeom prst="rect">
+            <a:avLst/>
+          </a:prstGeom>
+          <a:noFill/>
+        </p:spPr>
+        <p:txBody>
+          <a:bodyPr wrap="square">
+            <a:spAutoFit/>
+          </a:bodyPr>
+          <a:lstStyle/>
+          <a:p>
+            <a:pPr algn="l">
+              <a:defRPr sz="1200" b="0">
+                <a:solidFill>
+                  <a:srgbClr val="1E293B"/>
+                </a:solidFill>
+                <a:latin typeface="Malgun Gothic"/>
+              </a:defRPr>
+            </a:pPr>
+            <a:r>
+              <a:t>1. Phase 3 Day1~2: Bookmark model + Hive box + viewer 버튼 + 목록 (북마크)</a:t>
+            </a:r>
+          </a:p>
+        </p:txBody>
+      </p:sp>
+      <p:sp>
+        <p:nvSpPr>
+          <p:cNvPr id="7" name="Rounded Rectangle 6"/>
+          <p:cNvSpPr/>
+          <p:nvPr/>
+        </p:nvSpPr>
+        <p:spPr>
+          <a:xfrm>
+            <a:off x="457200" y="1325880"/>
+            <a:ext cx="8229600" cy="384048"/>
+          </a:xfrm>
+          <a:prstGeom prst="roundRect">
+            <a:avLst/>
+          </a:prstGeom>
+          <a:solidFill>
+            <a:srgbClr val="FFFFFF"/>
+          </a:solidFill>
+          <a:ln>
+            <a:solidFill>
+              <a:srgbClr val="E2E8F0"/>
+            </a:solidFill>
+          </a:ln>
+        </p:spPr>
+        <p:style>
+          <a:lnRef idx="1">
+            <a:schemeClr val="accent1"/>
+          </a:lnRef>
+          <a:fillRef idx="3">
+            <a:schemeClr val="accent1"/>
+          </a:fillRef>
+          <a:effectRef idx="2">
+            <a:schemeClr val="accent1"/>
+          </a:effectRef>
+          <a:fontRef idx="minor">
+            <a:schemeClr val="lt1"/>
+          </a:fontRef>
+        </p:style>
+        <p:txBody>
+          <a:bodyPr rtlCol="0" anchor="ctr"/>
+          <a:lstStyle/>
+          <a:p>
+            <a:pPr algn="ctr"/>
+          </a:p>
+        </p:txBody>
+      </p:sp>
+      <p:sp>
+        <p:nvSpPr>
+          <p:cNvPr id="8" name="TextBox 7"/>
+          <p:cNvSpPr txBox="1"/>
+          <p:nvPr/>
+        </p:nvSpPr>
+        <p:spPr>
+          <a:xfrm>
+            <a:off x="640080" y="1371600"/>
+            <a:ext cx="7863840" cy="320040"/>
+          </a:xfrm>
+          <a:prstGeom prst="rect">
+            <a:avLst/>
+          </a:prstGeom>
+          <a:noFill/>
+        </p:spPr>
+        <p:txBody>
+          <a:bodyPr wrap="square">
+            <a:spAutoFit/>
+          </a:bodyPr>
+          <a:lstStyle/>
+          <a:p>
+            <a:pPr algn="l">
+              <a:defRPr sz="1200" b="0">
+                <a:solidFill>
+                  <a:srgbClr val="1E293B"/>
+                </a:solidFill>
+                <a:latin typeface="Malgun Gothic"/>
+              </a:defRPr>
+            </a:pPr>
+            <a:r>
+              <a:t>2. Phase 3 Day2~3: 설정 화면 + 검색 결과 polish (글꼴/다크)</a:t>
+            </a:r>
+          </a:p>
+        </p:txBody>
+      </p:sp>
+      <p:sp>
+        <p:nvSpPr>
+          <p:cNvPr id="9" name="Rounded Rectangle 8"/>
+          <p:cNvSpPr/>
+          <p:nvPr/>
+        </p:nvSpPr>
+        <p:spPr>
+          <a:xfrm>
+            <a:off x="457200" y="1783080"/>
+            <a:ext cx="8229600" cy="384048"/>
+          </a:xfrm>
+          <a:prstGeom prst="roundRect">
+            <a:avLst/>
+          </a:prstGeom>
+          <a:solidFill>
+            <a:srgbClr val="FFFFFF"/>
+          </a:solidFill>
+          <a:ln>
+            <a:solidFill>
+              <a:srgbClr val="E2E8F0"/>
+            </a:solidFill>
+          </a:ln>
+        </p:spPr>
+        <p:style>
+          <a:lnRef idx="1">
+            <a:schemeClr val="accent1"/>
+          </a:lnRef>
+          <a:fillRef idx="3">
+            <a:schemeClr val="accent1"/>
+          </a:fillRef>
+          <a:effectRef idx="2">
+            <a:schemeClr val="accent1"/>
+          </a:effectRef>
+          <a:fontRef idx="minor">
+            <a:schemeClr val="lt1"/>
+          </a:fontRef>
+        </p:style>
+        <p:txBody>
+          <a:bodyPr rtlCol="0" anchor="ctr"/>
+          <a:lstStyle/>
+          <a:p>
+            <a:pPr algn="ctr"/>
+          </a:p>
+        </p:txBody>
+      </p:sp>
+      <p:sp>
+        <p:nvSpPr>
+          <p:cNvPr id="10" name="TextBox 9"/>
+          <p:cNvSpPr txBox="1"/>
+          <p:nvPr/>
+        </p:nvSpPr>
+        <p:spPr>
+          <a:xfrm>
+            <a:off x="640080" y="1828800"/>
+            <a:ext cx="7863840" cy="320040"/>
+          </a:xfrm>
+          <a:prstGeom prst="rect">
+            <a:avLst/>
+          </a:prstGeom>
+          <a:noFill/>
+        </p:spPr>
+        <p:txBody>
+          <a:bodyPr wrap="square">
+            <a:spAutoFit/>
+          </a:bodyPr>
+          <a:lstStyle/>
+          <a:p>
+            <a:pPr algn="l">
+              <a:defRPr sz="1200" b="0">
+                <a:solidFill>
+                  <a:srgbClr val="1E293B"/>
+                </a:solidFill>
+                <a:latin typeface="Malgun Gothic"/>
+              </a:defRPr>
+            </a:pPr>
+            <a:r>
+              <a:t>3. 찬송가 가사+악보, 사도신경, 주기도문, 교독문 + About 페이지 구현</a:t>
+            </a:r>
+          </a:p>
+        </p:txBody>
+      </p:sp>
+      <p:sp>
+        <p:nvSpPr>
+          <p:cNvPr id="11" name="Rounded Rectangle 10"/>
+          <p:cNvSpPr/>
+          <p:nvPr/>
+        </p:nvSpPr>
+        <p:spPr>
+          <a:xfrm>
+            <a:off x="457200" y="2240280"/>
+            <a:ext cx="8229600" cy="384048"/>
+          </a:xfrm>
+          <a:prstGeom prst="roundRect">
+            <a:avLst/>
+          </a:prstGeom>
+          <a:solidFill>
+            <a:srgbClr val="FFFFFF"/>
+          </a:solidFill>
+          <a:ln>
+            <a:solidFill>
+              <a:srgbClr val="E2E8F0"/>
+            </a:solidFill>
+          </a:ln>
+        </p:spPr>
+        <p:style>
+          <a:lnRef idx="1">
+            <a:schemeClr val="accent1"/>
+          </a:lnRef>
+          <a:fillRef idx="3">
+            <a:schemeClr val="accent1"/>
+          </a:fillRef>
+          <a:effectRef idx="2">
+            <a:schemeClr val="accent1"/>
+          </a:effectRef>
+          <a:fontRef idx="minor">
+            <a:schemeClr val="lt1"/>
+          </a:fontRef>
+        </p:style>
+        <p:txBody>
+          <a:bodyPr rtlCol="0" anchor="ctr"/>
+          <a:lstStyle/>
+          <a:p>
+            <a:pPr algn="ctr"/>
+          </a:p>
+        </p:txBody>
+      </p:sp>
+      <p:sp>
+        <p:nvSpPr>
+          <p:cNvPr id="12" name="TextBox 11"/>
+          <p:cNvSpPr txBox="1"/>
+          <p:nvPr/>
+        </p:nvSpPr>
+        <p:spPr>
+          <a:xfrm>
+            <a:off x="640080" y="2286000"/>
+            <a:ext cx="7863840" cy="320040"/>
+          </a:xfrm>
+          <a:prstGeom prst="rect">
+            <a:avLst/>
+          </a:prstGeom>
+          <a:noFill/>
+        </p:spPr>
+        <p:txBody>
+          <a:bodyPr wrap="square">
+            <a:spAutoFit/>
+          </a:bodyPr>
+          <a:lstStyle/>
+          <a:p>
+            <a:pPr algn="l">
+              <a:defRPr sz="1200" b="0">
+                <a:solidFill>
+                  <a:srgbClr val="1E293B"/>
+                </a:solidFill>
+                <a:latin typeface="Malgun Gothic"/>
+              </a:defRPr>
+            </a:pPr>
+            <a:r>
+              <a:t>4. Phase 4 Day1: Theme provider + 다크모드</a:t>
+            </a:r>
+          </a:p>
+        </p:txBody>
+      </p:sp>
+      <p:sp>
+        <p:nvSpPr>
+          <p:cNvPr id="13" name="Rounded Rectangle 12"/>
+          <p:cNvSpPr/>
+          <p:nvPr/>
+        </p:nvSpPr>
+        <p:spPr>
+          <a:xfrm>
+            <a:off x="457200" y="2697480"/>
+            <a:ext cx="8229600" cy="384048"/>
+          </a:xfrm>
+          <a:prstGeom prst="roundRect">
+            <a:avLst/>
+          </a:prstGeom>
+          <a:solidFill>
+            <a:srgbClr val="FFFFFF"/>
+          </a:solidFill>
+          <a:ln>
+            <a:solidFill>
+              <a:srgbClr val="E2E8F0"/>
+            </a:solidFill>
+          </a:ln>
+        </p:spPr>
+        <p:style>
+          <a:lnRef idx="1">
+            <a:schemeClr val="accent1"/>
+          </a:lnRef>
+          <a:fillRef idx="3">
+            <a:schemeClr val="accent1"/>
+          </a:fillRef>
+          <a:effectRef idx="2">
+            <a:schemeClr val="accent1"/>
+          </a:effectRef>
+          <a:fontRef idx="minor">
+            <a:schemeClr val="lt1"/>
+          </a:fontRef>
+        </p:style>
+        <p:txBody>
+          <a:bodyPr rtlCol="0" anchor="ctr"/>
+          <a:lstStyle/>
+          <a:p>
+            <a:pPr algn="ctr"/>
+          </a:p>
+        </p:txBody>
+      </p:sp>
+      <p:sp>
+        <p:nvSpPr>
+          <p:cNvPr id="14" name="TextBox 13"/>
+          <p:cNvSpPr txBox="1"/>
+          <p:nvPr/>
+        </p:nvSpPr>
+        <p:spPr>
+          <a:xfrm>
+            <a:off x="640080" y="2743200"/>
+            <a:ext cx="7863840" cy="320040"/>
+          </a:xfrm>
+          <a:prstGeom prst="rect">
+            <a:avLst/>
+          </a:prstGeom>
+          <a:noFill/>
+        </p:spPr>
+        <p:txBody>
+          <a:bodyPr wrap="square">
+            <a:spAutoFit/>
+          </a:bodyPr>
+          <a:lstStyle/>
+          <a:p>
+            <a:pPr algn="l">
+              <a:defRPr sz="1200" b="0">
+                <a:solidFill>
+                  <a:srgbClr val="1E293B"/>
+                </a:solidFill>
+                <a:latin typeface="Malgun Gothic"/>
+              </a:defRPr>
+            </a:pPr>
+            <a:r>
+              <a:t>5. Phase 4 Day3~5: 반응형 LayoutBuilder + 접근성</a:t>
+            </a:r>
+          </a:p>
+        </p:txBody>
+      </p:sp>
+      <p:sp>
+        <p:nvSpPr>
+          <p:cNvPr id="15" name="Rounded Rectangle 14"/>
+          <p:cNvSpPr/>
+          <p:nvPr/>
+        </p:nvSpPr>
+        <p:spPr>
+          <a:xfrm>
+            <a:off x="457200" y="3154680"/>
+            <a:ext cx="8229600" cy="384048"/>
+          </a:xfrm>
+          <a:prstGeom prst="roundRect">
+            <a:avLst/>
+          </a:prstGeom>
+          <a:solidFill>
+            <a:srgbClr val="FFFFFF"/>
+          </a:solidFill>
+          <a:ln>
+            <a:solidFill>
+              <a:srgbClr val="E2E8F0"/>
+            </a:solidFill>
+          </a:ln>
+        </p:spPr>
+        <p:style>
+          <a:lnRef idx="1">
+            <a:schemeClr val="accent1"/>
+          </a:lnRef>
+          <a:fillRef idx="3">
+            <a:schemeClr val="accent1"/>
+          </a:fillRef>
+          <a:effectRef idx="2">
+            <a:schemeClr val="accent1"/>
+          </a:effectRef>
+          <a:fontRef idx="minor">
+            <a:schemeClr val="lt1"/>
+          </a:fontRef>
+        </p:style>
+        <p:txBody>
+          <a:bodyPr rtlCol="0" anchor="ctr"/>
+          <a:lstStyle/>
+          <a:p>
+            <a:pPr algn="ctr"/>
+          </a:p>
+        </p:txBody>
+      </p:sp>
+      <p:sp>
+        <p:nvSpPr>
+          <p:cNvPr id="16" name="TextBox 15"/>
+          <p:cNvSpPr txBox="1"/>
+          <p:nvPr/>
+        </p:nvSpPr>
+        <p:spPr>
+          <a:xfrm>
+            <a:off x="640080" y="3200400"/>
+            <a:ext cx="7863840" cy="320040"/>
+          </a:xfrm>
+          <a:prstGeom prst="rect">
+            <a:avLst/>
+          </a:prstGeom>
+          <a:noFill/>
+        </p:spPr>
+        <p:txBody>
+          <a:bodyPr wrap="square">
+            <a:spAutoFit/>
+          </a:bodyPr>
+          <a:lstStyle/>
+          <a:p>
+            <a:pPr algn="l">
+              <a:defRPr sz="1200" b="0">
+                <a:solidFill>
+                  <a:srgbClr val="1E293B"/>
+                </a:solidFill>
+                <a:latin typeface="Malgun Gothic"/>
+              </a:defRPr>
+            </a:pPr>
+            <a:r>
+              <a:t>6. Phase 5 Day1~2: Android build + 테스트</a:t>
+            </a:r>
+          </a:p>
+        </p:txBody>
+      </p:sp>
+      <p:sp>
+        <p:nvSpPr>
+          <p:cNvPr id="17" name="Rounded Rectangle 16"/>
+          <p:cNvSpPr/>
+          <p:nvPr/>
+        </p:nvSpPr>
+        <p:spPr>
+          <a:xfrm>
+            <a:off x="457200" y="3611880"/>
+            <a:ext cx="8229600" cy="384048"/>
+          </a:xfrm>
+          <a:prstGeom prst="roundRect">
+            <a:avLst/>
+          </a:prstGeom>
+          <a:solidFill>
+            <a:srgbClr val="FFFFFF"/>
+          </a:solidFill>
+          <a:ln>
+            <a:solidFill>
+              <a:srgbClr val="E2E8F0"/>
+            </a:solidFill>
+          </a:ln>
+        </p:spPr>
+        <p:style>
+          <a:lnRef idx="1">
+            <a:schemeClr val="accent1"/>
+          </a:lnRef>
+          <a:fillRef idx="3">
+            <a:schemeClr val="accent1"/>
+          </a:fillRef>
+          <a:effectRef idx="2">
+            <a:schemeClr val="accent1"/>
+          </a:effectRef>
+          <a:fontRef idx="minor">
+            <a:schemeClr val="lt1"/>
+          </a:fontRef>
+        </p:style>
+        <p:txBody>
+          <a:bodyPr rtlCol="0" anchor="ctr"/>
+          <a:lstStyle/>
+          <a:p>
+            <a:pPr algn="ctr"/>
+          </a:p>
+        </p:txBody>
+      </p:sp>
+      <p:sp>
+        <p:nvSpPr>
+          <p:cNvPr id="18" name="TextBox 17"/>
+          <p:cNvSpPr txBox="1"/>
+          <p:nvPr/>
+        </p:nvSpPr>
+        <p:spPr>
+          <a:xfrm>
+            <a:off x="640080" y="3657600"/>
+            <a:ext cx="7863840" cy="320040"/>
+          </a:xfrm>
+          <a:prstGeom prst="rect">
+            <a:avLst/>
+          </a:prstGeom>
+          <a:noFill/>
+        </p:spPr>
+        <p:txBody>
+          <a:bodyPr wrap="square">
+            <a:spAutoFit/>
+          </a:bodyPr>
+          <a:lstStyle/>
+          <a:p>
+            <a:pPr algn="l">
+              <a:defRPr sz="1200" b="0">
+                <a:solidFill>
+                  <a:srgbClr val="1E293B"/>
+                </a:solidFill>
+                <a:latin typeface="Malgun Gothic"/>
+              </a:defRPr>
+            </a:pPr>
+            <a:r>
+              <a:t>7. Phase 5 Day2~4: iOS build + Xcode 테스트</a:t>
+            </a:r>
+          </a:p>
+        </p:txBody>
+      </p:sp>
+      <p:sp>
+        <p:nvSpPr>
+          <p:cNvPr id="19" name="Rounded Rectangle 18"/>
+          <p:cNvSpPr/>
+          <p:nvPr/>
+        </p:nvSpPr>
+        <p:spPr>
+          <a:xfrm>
+            <a:off x="457200" y="4069080"/>
+            <a:ext cx="8229600" cy="384048"/>
+          </a:xfrm>
+          <a:prstGeom prst="roundRect">
+            <a:avLst/>
+          </a:prstGeom>
+          <a:solidFill>
+            <a:srgbClr val="FFFFFF"/>
+          </a:solidFill>
+          <a:ln>
+            <a:solidFill>
+              <a:srgbClr val="E2E8F0"/>
+            </a:solidFill>
+          </a:ln>
+        </p:spPr>
+        <p:style>
+          <a:lnRef idx="1">
+            <a:schemeClr val="accent1"/>
+          </a:lnRef>
+          <a:fillRef idx="3">
+            <a:schemeClr val="accent1"/>
+          </a:fillRef>
+          <a:effectRef idx="2">
+            <a:schemeClr val="accent1"/>
+          </a:effectRef>
+          <a:fontRef idx="minor">
+            <a:schemeClr val="lt1"/>
+          </a:fontRef>
+        </p:style>
+        <p:txBody>
+          <a:bodyPr rtlCol="0" anchor="ctr"/>
+          <a:lstStyle/>
+          <a:p>
+            <a:pPr algn="ctr"/>
+          </a:p>
+        </p:txBody>
+      </p:sp>
+      <p:sp>
+        <p:nvSpPr>
+          <p:cNvPr id="20" name="TextBox 19"/>
+          <p:cNvSpPr txBox="1"/>
+          <p:nvPr/>
+        </p:nvSpPr>
+        <p:spPr>
+          <a:xfrm>
+            <a:off x="640080" y="4114800"/>
+            <a:ext cx="7863840" cy="320040"/>
+          </a:xfrm>
+          <a:prstGeom prst="rect">
+            <a:avLst/>
+          </a:prstGeom>
+          <a:noFill/>
+        </p:spPr>
+        <p:txBody>
+          <a:bodyPr wrap="square">
+            <a:spAutoFit/>
+          </a:bodyPr>
+          <a:lstStyle/>
+          <a:p>
+            <a:pPr algn="l">
+              <a:defRPr sz="1200" b="0">
+                <a:solidFill>
+                  <a:srgbClr val="1E293B"/>
+                </a:solidFill>
+                <a:latin typeface="Malgun Gothic"/>
+              </a:defRPr>
+            </a:pPr>
+            <a:r>
+              <a:t>8. Phase 5 Day4~7: Web PWA + 릴리스 + 스토어 준비</a:t>
+            </a:r>
+          </a:p>
+        </p:txBody>
+      </p:sp>
+      <p:sp>
+        <p:nvSpPr>
+          <p:cNvPr id="21" name="TextBox 20"/>
+          <p:cNvSpPr txBox="1"/>
+          <p:nvPr/>
+        </p:nvSpPr>
+        <p:spPr>
+          <a:xfrm>
+            <a:off x="457200" y="4663440"/>
+            <a:ext cx="8229600" cy="365760"/>
+          </a:xfrm>
+          <a:prstGeom prst="rect">
+            <a:avLst/>
+          </a:prstGeom>
+          <a:noFill/>
+        </p:spPr>
+        <p:txBody>
+          <a:bodyPr wrap="square">
+            <a:spAutoFit/>
+          </a:bodyPr>
+          <a:lstStyle/>
+          <a:p>
+            <a:pPr algn="l">
+              <a:defRPr sz="1000" b="0">
+                <a:solidFill>
+                  <a:srgbClr val="64748B"/>
+                </a:solidFill>
+                <a:latin typeface="Malgun Gothic"/>
+              </a:defRPr>
+            </a:pPr>
+            <a:r>
+              <a:t>상세 백로그: docs/Task_Prioritized_Backlog_and_Schedule_2026-06-19.md 참조</a:t>
+            </a:r>
+          </a:p>
+        </p:txBody>
+      </p:sp>
+    </p:spTree>
+  </p:cSld>
+  <p:clrMapOvr>
+    <a:masterClrMapping/>
+  </p:clrMapOvr>
+</p:sld>
+</file>
+
+<file path=ppt/slides/slide11.xml><?xml version="1.0" encoding="utf-8"?>
+<p:sld xmlns:a="http://schemas.openxmlformats.org/drawingml/2006/main" xmlns:p="http://schemas.openxmlformats.org/presentationml/2006/main" xmlns:r="http://schemas.openxmlformats.org/officeDocument/2006/relationships">
+  <p:cSld>
+    <p:spTree>
+      <p:nvGrpSpPr>
+        <p:cNvPr id="1" name=""/>
+        <p:cNvGrpSpPr/>
+        <p:nvPr/>
+      </p:nvGrpSpPr>
+      <p:grpSpPr/>
+      <p:sp>
+        <p:nvSpPr>
+          <p:cNvPr id="2" name="Rectangle 1"/>
+          <p:cNvSpPr/>
+          <p:nvPr/>
+        </p:nvSpPr>
+        <p:spPr>
+          <a:xfrm>
+            <a:off x="0" y="0"/>
+            <a:ext cx="9144000" cy="5143500"/>
+          </a:xfrm>
+          <a:prstGeom prst="rect">
+            <a:avLst/>
+          </a:prstGeom>
+          <a:solidFill>
+            <a:srgbClr val="F8FAFC"/>
+          </a:solidFill>
+          <a:ln>
+            <a:noFill/>
+          </a:ln>
+        </p:spPr>
+        <p:style>
+          <a:lnRef idx="1">
+            <a:schemeClr val="accent1"/>
+          </a:lnRef>
+          <a:fillRef idx="3">
+            <a:schemeClr val="accent1"/>
+          </a:fillRef>
+          <a:effectRef idx="2">
+            <a:schemeClr val="accent1"/>
+          </a:effectRef>
+          <a:fontRef idx="minor">
+            <a:schemeClr val="lt1"/>
+          </a:fontRef>
+        </p:style>
+        <p:txBody>
+          <a:bodyPr rtlCol="0" anchor="ctr"/>
+          <a:lstStyle/>
+          <a:p>
+            <a:pPr algn="ctr"/>
+          </a:p>
+        </p:txBody>
+      </p:sp>
+      <p:sp>
+        <p:nvSpPr>
+          <p:cNvPr id="3" name="Rectangle 2"/>
+          <p:cNvSpPr/>
+          <p:nvPr/>
+        </p:nvSpPr>
+        <p:spPr>
+          <a:xfrm>
+            <a:off x="0" y="0"/>
+            <a:ext cx="9144000" cy="73152"/>
+          </a:xfrm>
+          <a:prstGeom prst="rect">
+            <a:avLst/>
+          </a:prstGeom>
+          <a:solidFill>
             <a:srgbClr val="1E3A5F"/>
           </a:solidFill>
           <a:ln>
@@ -3865,16 +4690,16 @@
               </a:defRPr>
             </a:pPr>
             <a:r>
-              <a:t>로드맵 문서: docs/Project_Status_and_Updated_Roadmap_2026-06-19.md (40% 완료, 다음 Phase 3)</a:t>
+              <a:t>로드맵 문서: docs/Project_Status_and_Updated_Roadmap_2026-06-19.md (~65% 완료, Phase 3 ✅)</a:t>
             </a:r>
             <a:br/>
             <a:r>
-              <a:t>백로그: 상세 일/주 단위 + 시각적 트래킹 (Phase 3 북마크부터)</a:t>
+              <a:t>백로그: 즐겨찾기 하이라이트 + Phase 4 상세 | Gantt: 별도 슬라이드</a:t>
             </a:r>
             <a:br/>
             <a:br/>
             <a:r>
-              <a:t>현재: Phase 0-2 ✅ | 다음: Phase 3 ⏳ | 전체: 10슬라이드 PPTX 자동 생성</a:t>
+              <a:t>현재: Phase 0-3 ✅ | 다음: Phase 4 ⏳ | 마일스톤/Gantt 포함</a:t>
             </a:r>
           </a:p>
         </p:txBody>
@@ -4227,7 +5052,7 @@
               </a:defRPr>
             </a:pPr>
             <a:r>
-              <a:t>현재 상태 (2026-06-27)</a:t>
+              <a:t>현재 상태 (2026-06-28)</a:t>
             </a:r>
           </a:p>
         </p:txBody>
@@ -4263,7 +5088,7 @@
               </a:defRPr>
             </a:pPr>
             <a:r>
-              <a:t>전체 로드맵 진행률: ~40% 완료 (Phase 0-2 ✅ | Phase 3+ ⏳)</a:t>
+              <a:t>전체 로드맵 진행률: ~65% 완료 (Phase 0-3 ✅ | Phase 4 ⏳)</a:t>
             </a:r>
           </a:p>
         </p:txBody>
@@ -4320,7 +5145,7 @@
         <p:spPr>
           <a:xfrm>
             <a:off x="457200" y="1280160"/>
-            <a:ext cx="3291840" cy="228600"/>
+            <a:ext cx="5349240" cy="228600"/>
           </a:xfrm>
           <a:prstGeom prst="rect">
             <a:avLst/>
@@ -4385,7 +5210,7 @@
               </a:defRPr>
             </a:pPr>
             <a:r>
-              <a:t>Phase별: 0-2 ████ 100% | 3 ░░░░ 0% | 4-5 ░░░░ 0%</a:t>
+              <a:t>Phase별: 0-3 ██████ 95% | 4 ░░░░ 10% | 5 ░░░░ 0%</a:t>
             </a:r>
           </a:p>
         </p:txBody>
@@ -4420,19 +5245,15 @@
               </a:defRPr>
             </a:pPr>
             <a:r>
-              <a:t>✅ 완료된 상태 (전체 로드맵 대비 ~40%)</a:t>
+              <a:t>✅ 완료된 상태 (전체 로드맵 대비 ~65%)</a:t>
             </a:r>
             <a:br/>
             <a:r>
-              <a:t>• Phase 0: 기반, 의존성, 데이터, 스켈레톤, 빌드 ✅</a:t>
+              <a:t>• Phase 0-2: 기반 + 데이터 + 기본 읽기 UI (bilingual 검색, compact grid, home nav) ✅</a:t>
             </a:r>
             <a:br/>
             <a:r>
-              <a:t>• Phase 1: 모델 3개 + 어댑터 + JSON 로더 + 시드 ✅</a:t>
-            </a:r>
-            <a:br/>
-            <a:r>
-              <a:t>• Phase 2: 책목록(bilingual+검색+필터+본문검색), 장그리드, 뷰어(Rich+prev/next+홈), Provider, 디자인 ✅</a:t>
+              <a:t>• Phase 3: 북마크, 찬송가(검색+즐겨찾기), 신경/기도/교독문 dual, About, BottomNav, 다크+글꼴+highContrast ✅</a:t>
             </a:r>
             <a:br/>
             <a:br/>
@@ -4441,20 +5262,20 @@
             </a:r>
             <a:br/>
             <a:r>
-              <a:t>1. Phase 3 D1-2: 북마크 - model+Hive box + viewer 버튼 + 목록 화면 구현</a:t>
+              <a:t>1. 즐겨찾기 하이라이트 기능 (목록/본문 강조)</a:t>
             </a:r>
             <a:br/>
             <a:r>
-              <a:t>2. Phase 3 D2-3: 설정 화면 + 검색 결과 polish (글꼴/다크 토글)</a:t>
+              <a:t>2. Phase 4: dark polish, full responsive, accessibility</a:t>
             </a:r>
             <a:br/>
             <a:r>
-              <a:t>3. 찬송가(가사+악보), 사도신경, 주기도문, 교독문 화면 + "이 성경앱에 대해서" 추가 (메모 기능 완전 배제)</a:t>
+              <a:t>3. Loading/error full + branding (icon/splash)</a:t>
             </a:r>
             <a:br/>
             <a:br/>
             <a:r>
-              <a:t>남은 것: Phase 3 (북마크+추가콘텐츠+설정), Phase 4 (고도화), Phase 5 (배포) - 백로그에 일/주 단위 상세</a:t>
+              <a:t>남은 것: Phase 4 (고도화), Phase 5 (배포) - 상세 Gantt는 별도 슬라이드</a:t>
             </a:r>
           </a:p>
         </p:txBody>
@@ -4820,8 +5641,8 @@
         </p:nvSpPr>
         <p:spPr>
           <a:xfrm>
-            <a:off x="365760" y="1005840"/>
-            <a:ext cx="1325880" cy="2560320"/>
+            <a:off x="457200" y="1005840"/>
+            <a:ext cx="2011680" cy="2560320"/>
           </a:xfrm>
           <a:prstGeom prst="roundRect">
             <a:avLst/>
@@ -4865,8 +5686,8 @@
         </p:nvSpPr>
         <p:spPr>
           <a:xfrm>
-            <a:off x="365760" y="1005840"/>
-            <a:ext cx="1325880" cy="457200"/>
+            <a:off x="457200" y="1005840"/>
+            <a:ext cx="2011680" cy="457200"/>
           </a:xfrm>
           <a:prstGeom prst="rect">
             <a:avLst/>
@@ -4908,8 +5729,8 @@
         </p:nvSpPr>
         <p:spPr>
           <a:xfrm>
-            <a:off x="411480" y="1078992"/>
-            <a:ext cx="1234439" cy="365760"/>
+            <a:off x="502920" y="1078992"/>
+            <a:ext cx="1920240" cy="365760"/>
           </a:xfrm>
           <a:prstGeom prst="rect">
             <a:avLst/>
@@ -4931,7 +5752,7 @@
               </a:defRPr>
             </a:pPr>
             <a:r>
-              <a:t>Phase 0</a:t>
+              <a:t>Phase 0-2</a:t>
             </a:r>
           </a:p>
         </p:txBody>
@@ -4944,8 +5765,8 @@
         </p:nvSpPr>
         <p:spPr>
           <a:xfrm>
-            <a:off x="411480" y="1554480"/>
-            <a:ext cx="1234439" cy="548640"/>
+            <a:off x="502920" y="1554480"/>
+            <a:ext cx="1920240" cy="548640"/>
           </a:xfrm>
           <a:prstGeom prst="rect">
             <a:avLst/>
@@ -4967,7 +5788,11 @@
               </a:defRPr>
             </a:pPr>
             <a:r>
-              <a:t>기반 구축</a:t>
+              <a:t>MVP 읽기 UI</a:t>
+            </a:r>
+            <a:br/>
+            <a:r>
+              <a:t>(~6/27 완료)</a:t>
             </a:r>
           </a:p>
         </p:txBody>
@@ -4980,8 +5805,8 @@
         </p:nvSpPr>
         <p:spPr>
           <a:xfrm>
-            <a:off x="411480" y="2286000"/>
-            <a:ext cx="1234439" cy="320040"/>
+            <a:off x="502920" y="2286000"/>
+            <a:ext cx="1920240" cy="320040"/>
           </a:xfrm>
           <a:prstGeom prst="rect">
             <a:avLst/>
@@ -5016,8 +5841,8 @@
         </p:nvSpPr>
         <p:spPr>
           <a:xfrm>
-            <a:off x="1764792" y="1005840"/>
-            <a:ext cx="1325880" cy="2560320"/>
+            <a:off x="2606040" y="1005840"/>
+            <a:ext cx="2011680" cy="2560320"/>
           </a:xfrm>
           <a:prstGeom prst="roundRect">
             <a:avLst/>
@@ -5061,14 +5886,14 @@
         </p:nvSpPr>
         <p:spPr>
           <a:xfrm>
-            <a:off x="1764792" y="1005840"/>
-            <a:ext cx="1325880" cy="457200"/>
+            <a:off x="2606040" y="1005840"/>
+            <a:ext cx="2011680" cy="457200"/>
           </a:xfrm>
           <a:prstGeom prst="rect">
             <a:avLst/>
           </a:prstGeom>
           <a:solidFill>
-            <a:srgbClr val="1E3A5F"/>
+            <a:srgbClr val="0D9488"/>
           </a:solidFill>
           <a:ln>
             <a:noFill/>
@@ -5104,8 +5929,8 @@
         </p:nvSpPr>
         <p:spPr>
           <a:xfrm>
-            <a:off x="1810512" y="1078992"/>
-            <a:ext cx="1234439" cy="365760"/>
+            <a:off x="2651760" y="1078992"/>
+            <a:ext cx="1920240" cy="365760"/>
           </a:xfrm>
           <a:prstGeom prst="rect">
             <a:avLst/>
@@ -5127,7 +5952,7 @@
               </a:defRPr>
             </a:pPr>
             <a:r>
-              <a:t>Phase 1</a:t>
+              <a:t>Phase 3</a:t>
             </a:r>
           </a:p>
         </p:txBody>
@@ -5140,8 +5965,8 @@
         </p:nvSpPr>
         <p:spPr>
           <a:xfrm>
-            <a:off x="1810512" y="1554480"/>
-            <a:ext cx="1234439" cy="548640"/>
+            <a:off x="2651760" y="1554480"/>
+            <a:ext cx="1920240" cy="548640"/>
           </a:xfrm>
           <a:prstGeom prst="rect">
             <a:avLst/>
@@ -5163,7 +5988,11 @@
               </a:defRPr>
             </a:pPr>
             <a:r>
-              <a:t>데이터 계층</a:t>
+              <a:t>기능+콘텐츠</a:t>
+            </a:r>
+            <a:br/>
+            <a:r>
+              <a:t>(~7/10 목표)</a:t>
             </a:r>
           </a:p>
         </p:txBody>
@@ -5176,8 +6005,8 @@
         </p:nvSpPr>
         <p:spPr>
           <a:xfrm>
-            <a:off x="1810512" y="2286000"/>
-            <a:ext cx="1234439" cy="320040"/>
+            <a:off x="2651760" y="2286000"/>
+            <a:ext cx="1920240" cy="320040"/>
           </a:xfrm>
           <a:prstGeom prst="rect">
             <a:avLst/>
@@ -5212,8 +6041,8 @@
         </p:nvSpPr>
         <p:spPr>
           <a:xfrm>
-            <a:off x="3163824" y="1005840"/>
-            <a:ext cx="1325880" cy="2560320"/>
+            <a:off x="4754880" y="1005840"/>
+            <a:ext cx="2011680" cy="2560320"/>
           </a:xfrm>
           <a:prstGeom prst="roundRect">
             <a:avLst/>
@@ -5257,14 +6086,14 @@
         </p:nvSpPr>
         <p:spPr>
           <a:xfrm>
-            <a:off x="3163824" y="1005840"/>
-            <a:ext cx="1325880" cy="457200"/>
+            <a:off x="4754880" y="1005840"/>
+            <a:ext cx="2011680" cy="457200"/>
           </a:xfrm>
           <a:prstGeom prst="rect">
             <a:avLst/>
           </a:prstGeom>
           <a:solidFill>
-            <a:srgbClr val="1E3A5F"/>
+            <a:srgbClr val="D97706"/>
           </a:solidFill>
           <a:ln>
             <a:noFill/>
@@ -5300,8 +6129,8 @@
         </p:nvSpPr>
         <p:spPr>
           <a:xfrm>
-            <a:off x="3209544" y="1078992"/>
-            <a:ext cx="1234439" cy="365760"/>
+            <a:off x="4800600" y="1078992"/>
+            <a:ext cx="1920240" cy="365760"/>
           </a:xfrm>
           <a:prstGeom prst="rect">
             <a:avLst/>
@@ -5323,7 +6152,7 @@
               </a:defRPr>
             </a:pPr>
             <a:r>
-              <a:t>Phase 2</a:t>
+              <a:t>Phase 4</a:t>
             </a:r>
           </a:p>
         </p:txBody>
@@ -5336,8 +6165,8 @@
         </p:nvSpPr>
         <p:spPr>
           <a:xfrm>
-            <a:off x="3209544" y="1554480"/>
-            <a:ext cx="1234439" cy="548640"/>
+            <a:off x="4800600" y="1554480"/>
+            <a:ext cx="1920240" cy="548640"/>
           </a:xfrm>
           <a:prstGeom prst="rect">
             <a:avLst/>
@@ -5359,7 +6188,11 @@
               </a:defRPr>
             </a:pPr>
             <a:r>
-              <a:t>기본 읽기 UI</a:t>
+              <a:t>고도화</a:t>
+            </a:r>
+            <a:br/>
+            <a:r>
+              <a:t>(~7/20 목표)</a:t>
             </a:r>
           </a:p>
         </p:txBody>
@@ -5372,8 +6205,8 @@
         </p:nvSpPr>
         <p:spPr>
           <a:xfrm>
-            <a:off x="3209544" y="2286000"/>
-            <a:ext cx="1234439" cy="320040"/>
+            <a:off x="4800600" y="2286000"/>
+            <a:ext cx="1920240" cy="320040"/>
           </a:xfrm>
           <a:prstGeom prst="rect">
             <a:avLst/>
@@ -5395,7 +6228,7 @@
               </a:defRPr>
             </a:pPr>
             <a:r>
-              <a:t>✅ 완료</a:t>
+              <a:t>⏳ 진행</a:t>
             </a:r>
           </a:p>
         </p:txBody>
@@ -5408,8 +6241,8 @@
         </p:nvSpPr>
         <p:spPr>
           <a:xfrm>
-            <a:off x="4562856" y="1005840"/>
-            <a:ext cx="1325880" cy="2560320"/>
+            <a:off x="6903720" y="1005840"/>
+            <a:ext cx="2011680" cy="2560320"/>
           </a:xfrm>
           <a:prstGeom prst="roundRect">
             <a:avLst/>
@@ -5453,204 +6286,8 @@
         </p:nvSpPr>
         <p:spPr>
           <a:xfrm>
-            <a:off x="4562856" y="1005840"/>
-            <a:ext cx="1325880" cy="457200"/>
-          </a:xfrm>
-          <a:prstGeom prst="rect">
-            <a:avLst/>
-          </a:prstGeom>
-          <a:solidFill>
-            <a:srgbClr val="0D9488"/>
-          </a:solidFill>
-          <a:ln>
-            <a:noFill/>
-          </a:ln>
-        </p:spPr>
-        <p:style>
-          <a:lnRef idx="1">
-            <a:schemeClr val="accent1"/>
-          </a:lnRef>
-          <a:fillRef idx="3">
-            <a:schemeClr val="accent1"/>
-          </a:fillRef>
-          <a:effectRef idx="2">
-            <a:schemeClr val="accent1"/>
-          </a:effectRef>
-          <a:fontRef idx="minor">
-            <a:schemeClr val="lt1"/>
-          </a:fontRef>
-        </p:style>
-        <p:txBody>
-          <a:bodyPr rtlCol="0" anchor="ctr"/>
-          <a:lstStyle/>
-          <a:p>
-            <a:pPr algn="ctr"/>
-          </a:p>
-        </p:txBody>
-      </p:sp>
-      <p:sp>
-        <p:nvSpPr>
-          <p:cNvPr id="22" name="TextBox 21"/>
-          <p:cNvSpPr txBox="1"/>
-          <p:nvPr/>
-        </p:nvSpPr>
-        <p:spPr>
-          <a:xfrm>
-            <a:off x="4608576" y="1078992"/>
-            <a:ext cx="1234439" cy="365760"/>
-          </a:xfrm>
-          <a:prstGeom prst="rect">
-            <a:avLst/>
-          </a:prstGeom>
-          <a:noFill/>
-        </p:spPr>
-        <p:txBody>
-          <a:bodyPr wrap="square">
-            <a:spAutoFit/>
-          </a:bodyPr>
-          <a:lstStyle/>
-          <a:p>
-            <a:pPr algn="ctr">
-              <a:defRPr sz="1100" b="1">
-                <a:solidFill>
-                  <a:srgbClr val="FFFFFF"/>
-                </a:solidFill>
-                <a:latin typeface="Malgun Gothic"/>
-              </a:defRPr>
-            </a:pPr>
-            <a:r>
-              <a:t>Phase 3</a:t>
-            </a:r>
-          </a:p>
-        </p:txBody>
-      </p:sp>
-      <p:sp>
-        <p:nvSpPr>
-          <p:cNvPr id="23" name="TextBox 22"/>
-          <p:cNvSpPr txBox="1"/>
-          <p:nvPr/>
-        </p:nvSpPr>
-        <p:spPr>
-          <a:xfrm>
-            <a:off x="4608576" y="1554480"/>
-            <a:ext cx="1234439" cy="548640"/>
-          </a:xfrm>
-          <a:prstGeom prst="rect">
-            <a:avLst/>
-          </a:prstGeom>
-          <a:noFill/>
-        </p:spPr>
-        <p:txBody>
-          <a:bodyPr wrap="square">
-            <a:spAutoFit/>
-          </a:bodyPr>
-          <a:lstStyle/>
-          <a:p>
-            <a:pPr algn="ctr">
-              <a:defRPr sz="1000" b="1">
-                <a:solidFill>
-                  <a:srgbClr val="1E293B"/>
-                </a:solidFill>
-                <a:latin typeface="Malgun Gothic"/>
-              </a:defRPr>
-            </a:pPr>
-            <a:r>
-              <a:t>사용자 기능</a:t>
-            </a:r>
-          </a:p>
-        </p:txBody>
-      </p:sp>
-      <p:sp>
-        <p:nvSpPr>
-          <p:cNvPr id="24" name="TextBox 23"/>
-          <p:cNvSpPr txBox="1"/>
-          <p:nvPr/>
-        </p:nvSpPr>
-        <p:spPr>
-          <a:xfrm>
-            <a:off x="4608576" y="2286000"/>
-            <a:ext cx="1234439" cy="320040"/>
-          </a:xfrm>
-          <a:prstGeom prst="rect">
-            <a:avLst/>
-          </a:prstGeom>
-          <a:noFill/>
-        </p:spPr>
-        <p:txBody>
-          <a:bodyPr wrap="square">
-            <a:spAutoFit/>
-          </a:bodyPr>
-          <a:lstStyle/>
-          <a:p>
-            <a:pPr algn="ctr">
-              <a:defRPr sz="900" b="1">
-                <a:solidFill>
-                  <a:srgbClr val="D97706"/>
-                </a:solidFill>
-                <a:latin typeface="Malgun Gothic"/>
-              </a:defRPr>
-            </a:pPr>
-            <a:r>
-              <a:t>⏳ 다음</a:t>
-            </a:r>
-          </a:p>
-        </p:txBody>
-      </p:sp>
-      <p:sp>
-        <p:nvSpPr>
-          <p:cNvPr id="25" name="Rounded Rectangle 24"/>
-          <p:cNvSpPr/>
-          <p:nvPr/>
-        </p:nvSpPr>
-        <p:spPr>
-          <a:xfrm>
-            <a:off x="5961888" y="1005840"/>
-            <a:ext cx="1325880" cy="2560320"/>
-          </a:xfrm>
-          <a:prstGeom prst="roundRect">
-            <a:avLst/>
-          </a:prstGeom>
-          <a:solidFill>
-            <a:srgbClr val="FFFFFF"/>
-          </a:solidFill>
-          <a:ln>
-            <a:solidFill>
-              <a:srgbClr val="E2E8F0"/>
-            </a:solidFill>
-          </a:ln>
-        </p:spPr>
-        <p:style>
-          <a:lnRef idx="1">
-            <a:schemeClr val="accent1"/>
-          </a:lnRef>
-          <a:fillRef idx="3">
-            <a:schemeClr val="accent1"/>
-          </a:fillRef>
-          <a:effectRef idx="2">
-            <a:schemeClr val="accent1"/>
-          </a:effectRef>
-          <a:fontRef idx="minor">
-            <a:schemeClr val="lt1"/>
-          </a:fontRef>
-        </p:style>
-        <p:txBody>
-          <a:bodyPr rtlCol="0" anchor="ctr"/>
-          <a:lstStyle/>
-          <a:p>
-            <a:pPr algn="ctr"/>
-          </a:p>
-        </p:txBody>
-      </p:sp>
-      <p:sp>
-        <p:nvSpPr>
-          <p:cNvPr id="26" name="Rectangle 25"/>
-          <p:cNvSpPr/>
-          <p:nvPr/>
-        </p:nvSpPr>
-        <p:spPr>
-          <a:xfrm>
-            <a:off x="5961888" y="1005840"/>
-            <a:ext cx="1325880" cy="457200"/>
+            <a:off x="6903720" y="1005840"/>
+            <a:ext cx="2011680" cy="457200"/>
           </a:xfrm>
           <a:prstGeom prst="rect">
             <a:avLst/>
@@ -5686,14 +6323,14 @@
       </p:sp>
       <p:sp>
         <p:nvSpPr>
-          <p:cNvPr id="27" name="TextBox 26"/>
+          <p:cNvPr id="22" name="TextBox 21"/>
           <p:cNvSpPr txBox="1"/>
           <p:nvPr/>
         </p:nvSpPr>
         <p:spPr>
           <a:xfrm>
-            <a:off x="6007608" y="1078992"/>
-            <a:ext cx="1234439" cy="365760"/>
+            <a:off x="6949440" y="1078992"/>
+            <a:ext cx="1920240" cy="365760"/>
           </a:xfrm>
           <a:prstGeom prst="rect">
             <a:avLst/>
@@ -5715,21 +6352,21 @@
               </a:defRPr>
             </a:pPr>
             <a:r>
-              <a:t>Phase 4</a:t>
-            </a:r>
-          </a:p>
-        </p:txBody>
-      </p:sp>
-      <p:sp>
-        <p:nvSpPr>
-          <p:cNvPr id="28" name="TextBox 27"/>
+              <a:t>Phase 5</a:t>
+            </a:r>
+          </a:p>
+        </p:txBody>
+      </p:sp>
+      <p:sp>
+        <p:nvSpPr>
+          <p:cNvPr id="23" name="TextBox 22"/>
           <p:cNvSpPr txBox="1"/>
           <p:nvPr/>
         </p:nvSpPr>
         <p:spPr>
           <a:xfrm>
-            <a:off x="6007608" y="1554480"/>
-            <a:ext cx="1234439" cy="548640"/>
+            <a:off x="6949440" y="1554480"/>
+            <a:ext cx="1920240" cy="548640"/>
           </a:xfrm>
           <a:prstGeom prst="rect">
             <a:avLst/>
@@ -5751,21 +6388,25 @@
               </a:defRPr>
             </a:pPr>
             <a:r>
-              <a:t>UI/UX 고도화</a:t>
-            </a:r>
-          </a:p>
-        </p:txBody>
-      </p:sp>
-      <p:sp>
-        <p:nvSpPr>
-          <p:cNvPr id="29" name="TextBox 28"/>
+              <a:t>배포</a:t>
+            </a:r>
+            <a:br/>
+            <a:r>
+              <a:t>(~7/25+ 목표)</a:t>
+            </a:r>
+          </a:p>
+        </p:txBody>
+      </p:sp>
+      <p:sp>
+        <p:nvSpPr>
+          <p:cNvPr id="24" name="TextBox 23"/>
           <p:cNvSpPr txBox="1"/>
           <p:nvPr/>
         </p:nvSpPr>
         <p:spPr>
           <a:xfrm>
-            <a:off x="6007608" y="2286000"/>
-            <a:ext cx="1234439" cy="320040"/>
+            <a:off x="6949440" y="2286000"/>
+            <a:ext cx="1920240" cy="320040"/>
           </a:xfrm>
           <a:prstGeom prst="rect">
             <a:avLst/>
@@ -5787,210 +6428,14 @@
               </a:defRPr>
             </a:pPr>
             <a:r>
-              <a:t>⏳ 미완</a:t>
-            </a:r>
-          </a:p>
-        </p:txBody>
-      </p:sp>
-      <p:sp>
-        <p:nvSpPr>
-          <p:cNvPr id="30" name="Rounded Rectangle 29"/>
-          <p:cNvSpPr/>
-          <p:nvPr/>
-        </p:nvSpPr>
-        <p:spPr>
-          <a:xfrm>
-            <a:off x="7360920" y="1005840"/>
-            <a:ext cx="1325880" cy="2560320"/>
-          </a:xfrm>
-          <a:prstGeom prst="roundRect">
-            <a:avLst/>
-          </a:prstGeom>
-          <a:solidFill>
-            <a:srgbClr val="FFFFFF"/>
-          </a:solidFill>
-          <a:ln>
-            <a:solidFill>
-              <a:srgbClr val="E2E8F0"/>
-            </a:solidFill>
-          </a:ln>
-        </p:spPr>
-        <p:style>
-          <a:lnRef idx="1">
-            <a:schemeClr val="accent1"/>
-          </a:lnRef>
-          <a:fillRef idx="3">
-            <a:schemeClr val="accent1"/>
-          </a:fillRef>
-          <a:effectRef idx="2">
-            <a:schemeClr val="accent1"/>
-          </a:effectRef>
-          <a:fontRef idx="minor">
-            <a:schemeClr val="lt1"/>
-          </a:fontRef>
-        </p:style>
-        <p:txBody>
-          <a:bodyPr rtlCol="0" anchor="ctr"/>
-          <a:lstStyle/>
-          <a:p>
-            <a:pPr algn="ctr"/>
-          </a:p>
-        </p:txBody>
-      </p:sp>
-      <p:sp>
-        <p:nvSpPr>
-          <p:cNvPr id="31" name="Rectangle 30"/>
-          <p:cNvSpPr/>
-          <p:nvPr/>
-        </p:nvSpPr>
-        <p:spPr>
-          <a:xfrm>
-            <a:off x="7360920" y="1005840"/>
-            <a:ext cx="1325880" cy="457200"/>
-          </a:xfrm>
-          <a:prstGeom prst="rect">
-            <a:avLst/>
-          </a:prstGeom>
-          <a:solidFill>
-            <a:srgbClr val="D97706"/>
-          </a:solidFill>
-          <a:ln>
-            <a:noFill/>
-          </a:ln>
-        </p:spPr>
-        <p:style>
-          <a:lnRef idx="1">
-            <a:schemeClr val="accent1"/>
-          </a:lnRef>
-          <a:fillRef idx="3">
-            <a:schemeClr val="accent1"/>
-          </a:fillRef>
-          <a:effectRef idx="2">
-            <a:schemeClr val="accent1"/>
-          </a:effectRef>
-          <a:fontRef idx="minor">
-            <a:schemeClr val="lt1"/>
-          </a:fontRef>
-        </p:style>
-        <p:txBody>
-          <a:bodyPr rtlCol="0" anchor="ctr"/>
-          <a:lstStyle/>
-          <a:p>
-            <a:pPr algn="ctr"/>
-          </a:p>
-        </p:txBody>
-      </p:sp>
-      <p:sp>
-        <p:nvSpPr>
-          <p:cNvPr id="32" name="TextBox 31"/>
-          <p:cNvSpPr txBox="1"/>
-          <p:nvPr/>
-        </p:nvSpPr>
-        <p:spPr>
-          <a:xfrm>
-            <a:off x="7406640" y="1078992"/>
-            <a:ext cx="1234439" cy="365760"/>
-          </a:xfrm>
-          <a:prstGeom prst="rect">
-            <a:avLst/>
-          </a:prstGeom>
-          <a:noFill/>
-        </p:spPr>
-        <p:txBody>
-          <a:bodyPr wrap="square">
-            <a:spAutoFit/>
-          </a:bodyPr>
-          <a:lstStyle/>
-          <a:p>
-            <a:pPr algn="ctr">
-              <a:defRPr sz="1100" b="1">
-                <a:solidFill>
-                  <a:srgbClr val="FFFFFF"/>
-                </a:solidFill>
-                <a:latin typeface="Malgun Gothic"/>
-              </a:defRPr>
-            </a:pPr>
-            <a:r>
-              <a:t>Phase 5</a:t>
-            </a:r>
-          </a:p>
-        </p:txBody>
-      </p:sp>
-      <p:sp>
-        <p:nvSpPr>
-          <p:cNvPr id="33" name="TextBox 32"/>
-          <p:cNvSpPr txBox="1"/>
-          <p:nvPr/>
-        </p:nvSpPr>
-        <p:spPr>
-          <a:xfrm>
-            <a:off x="7406640" y="1554480"/>
-            <a:ext cx="1234439" cy="548640"/>
-          </a:xfrm>
-          <a:prstGeom prst="rect">
-            <a:avLst/>
-          </a:prstGeom>
-          <a:noFill/>
-        </p:spPr>
-        <p:txBody>
-          <a:bodyPr wrap="square">
-            <a:spAutoFit/>
-          </a:bodyPr>
-          <a:lstStyle/>
-          <a:p>
-            <a:pPr algn="ctr">
-              <a:defRPr sz="1000" b="1">
-                <a:solidFill>
-                  <a:srgbClr val="1E293B"/>
-                </a:solidFill>
-                <a:latin typeface="Malgun Gothic"/>
-              </a:defRPr>
-            </a:pPr>
-            <a:r>
-              <a:t>배포 &amp; 플랫폼</a:t>
-            </a:r>
-          </a:p>
-        </p:txBody>
-      </p:sp>
-      <p:sp>
-        <p:nvSpPr>
-          <p:cNvPr id="34" name="TextBox 33"/>
-          <p:cNvSpPr txBox="1"/>
-          <p:nvPr/>
-        </p:nvSpPr>
-        <p:spPr>
-          <a:xfrm>
-            <a:off x="7406640" y="2286000"/>
-            <a:ext cx="1234439" cy="320040"/>
-          </a:xfrm>
-          <a:prstGeom prst="rect">
-            <a:avLst/>
-          </a:prstGeom>
-          <a:noFill/>
-        </p:spPr>
-        <p:txBody>
-          <a:bodyPr wrap="square">
-            <a:spAutoFit/>
-          </a:bodyPr>
-          <a:lstStyle/>
-          <a:p>
-            <a:pPr algn="ctr">
-              <a:defRPr sz="900" b="1">
-                <a:solidFill>
-                  <a:srgbClr val="D97706"/>
-                </a:solidFill>
-                <a:latin typeface="Malgun Gothic"/>
-              </a:defRPr>
-            </a:pPr>
-            <a:r>
-              <a:t>⏳ 미완</a:t>
-            </a:r>
-          </a:p>
-        </p:txBody>
-      </p:sp>
-      <p:sp>
-        <p:nvSpPr>
-          <p:cNvPr id="35" name="TextBox 34"/>
+              <a:t>⏳ 예정</a:t>
+            </a:r>
+          </a:p>
+        </p:txBody>
+      </p:sp>
+      <p:sp>
+        <p:nvSpPr>
+          <p:cNvPr id="25" name="TextBox 24"/>
           <p:cNvSpPr txBox="1"/>
           <p:nvPr/>
         </p:nvSpPr>
@@ -6100,7 +6545,7 @@
             <a:avLst/>
           </a:prstGeom>
           <a:solidFill>
-            <a:srgbClr val="0D9488"/>
+            <a:srgbClr val="D97706"/>
           </a:solidFill>
           <a:ln>
             <a:noFill/>
@@ -6137,7 +6582,7 @@
         <p:spPr>
           <a:xfrm>
             <a:off x="457200" y="228600"/>
-            <a:ext cx="8229600" cy="548640"/>
+            <a:ext cx="8229600" cy="457200"/>
           </a:xfrm>
           <a:prstGeom prst="rect">
             <a:avLst/>
@@ -6159,23 +6604,311 @@
               </a:defRPr>
             </a:pPr>
             <a:r>
-              <a:t>Phase 1: 데이터 계층 (최우선)</a:t>
-            </a:r>
-          </a:p>
-        </p:txBody>
-      </p:sp>
-      <p:sp>
-        <p:nvSpPr>
-          <p:cNvPr id="5" name="Oval 4"/>
+              <a:t>마일스톤 &amp; 간트 차트 (일정)</a:t>
+            </a:r>
+          </a:p>
+        </p:txBody>
+      </p:sp>
+      <p:sp>
+        <p:nvSpPr>
+          <p:cNvPr id="5" name="TextBox 4"/>
+          <p:cNvSpPr txBox="1"/>
+          <p:nvPr/>
+        </p:nvSpPr>
+        <p:spPr>
+          <a:xfrm>
+            <a:off x="457200" y="822960"/>
+            <a:ext cx="4114800" cy="365760"/>
+          </a:xfrm>
+          <a:prstGeom prst="rect">
+            <a:avLst/>
+          </a:prstGeom>
+          <a:noFill/>
+        </p:spPr>
+        <p:txBody>
+          <a:bodyPr wrap="square">
+            <a:spAutoFit/>
+          </a:bodyPr>
+          <a:lstStyle/>
+          <a:p>
+            <a:pPr algn="l">
+              <a:defRPr sz="1400" b="1">
+                <a:solidFill>
+                  <a:srgbClr val="0D9488"/>
+                </a:solidFill>
+                <a:latin typeface="Malgun Gothic"/>
+              </a:defRPr>
+            </a:pPr>
+            <a:r>
+              <a:t>주요 마일스톤</a:t>
+            </a:r>
+          </a:p>
+        </p:txBody>
+      </p:sp>
+      <p:sp>
+        <p:nvSpPr>
+          <p:cNvPr id="6" name="TextBox 5"/>
+          <p:cNvSpPr txBox="1"/>
+          <p:nvPr/>
+        </p:nvSpPr>
+        <p:spPr>
+          <a:xfrm>
+            <a:off x="457200" y="1188720"/>
+            <a:ext cx="4114800" cy="320040"/>
+          </a:xfrm>
+          <a:prstGeom prst="rect">
+            <a:avLst/>
+          </a:prstGeom>
+          <a:noFill/>
+        </p:spPr>
+        <p:txBody>
+          <a:bodyPr wrap="square">
+            <a:spAutoFit/>
+          </a:bodyPr>
+          <a:lstStyle/>
+          <a:p>
+            <a:pPr algn="l">
+              <a:defRPr sz="1100" b="0">
+                <a:solidFill>
+                  <a:srgbClr val="1E293B"/>
+                </a:solidFill>
+                <a:latin typeface="Malgun Gothic"/>
+              </a:defRPr>
+            </a:pPr>
+            <a:r>
+              <a:t>• M1: Phase 0-2 완료 (MVP) - 2026-06-27 ✅</a:t>
+            </a:r>
+          </a:p>
+        </p:txBody>
+      </p:sp>
+      <p:sp>
+        <p:nvSpPr>
+          <p:cNvPr id="7" name="TextBox 6"/>
+          <p:cNvSpPr txBox="1"/>
+          <p:nvPr/>
+        </p:nvSpPr>
+        <p:spPr>
+          <a:xfrm>
+            <a:off x="457200" y="1508760"/>
+            <a:ext cx="4114800" cy="320040"/>
+          </a:xfrm>
+          <a:prstGeom prst="rect">
+            <a:avLst/>
+          </a:prstGeom>
+          <a:noFill/>
+        </p:spPr>
+        <p:txBody>
+          <a:bodyPr wrap="square">
+            <a:spAutoFit/>
+          </a:bodyPr>
+          <a:lstStyle/>
+          <a:p>
+            <a:pPr algn="l">
+              <a:defRPr sz="1100" b="0">
+                <a:solidFill>
+                  <a:srgbClr val="1E293B"/>
+                </a:solidFill>
+                <a:latin typeface="Malgun Gothic"/>
+              </a:defRPr>
+            </a:pPr>
+            <a:r>
+              <a:t>• M2: Phase 3 완료 (기능+콘텐츠) - 2026-07-10</a:t>
+            </a:r>
+          </a:p>
+        </p:txBody>
+      </p:sp>
+      <p:sp>
+        <p:nvSpPr>
+          <p:cNvPr id="8" name="TextBox 7"/>
+          <p:cNvSpPr txBox="1"/>
+          <p:nvPr/>
+        </p:nvSpPr>
+        <p:spPr>
+          <a:xfrm>
+            <a:off x="457200" y="1828800"/>
+            <a:ext cx="4114800" cy="320040"/>
+          </a:xfrm>
+          <a:prstGeom prst="rect">
+            <a:avLst/>
+          </a:prstGeom>
+          <a:noFill/>
+        </p:spPr>
+        <p:txBody>
+          <a:bodyPr wrap="square">
+            <a:spAutoFit/>
+          </a:bodyPr>
+          <a:lstStyle/>
+          <a:p>
+            <a:pPr algn="l">
+              <a:defRPr sz="1100" b="0">
+                <a:solidFill>
+                  <a:srgbClr val="1E293B"/>
+                </a:solidFill>
+                <a:latin typeface="Malgun Gothic"/>
+              </a:defRPr>
+            </a:pPr>
+            <a:r>
+              <a:t>• M3: Phase 4 완료 (고도화) - 2026-07-20</a:t>
+            </a:r>
+          </a:p>
+        </p:txBody>
+      </p:sp>
+      <p:sp>
+        <p:nvSpPr>
+          <p:cNvPr id="9" name="TextBox 8"/>
+          <p:cNvSpPr txBox="1"/>
+          <p:nvPr/>
+        </p:nvSpPr>
+        <p:spPr>
+          <a:xfrm>
+            <a:off x="457200" y="2148840"/>
+            <a:ext cx="4114800" cy="320040"/>
+          </a:xfrm>
+          <a:prstGeom prst="rect">
+            <a:avLst/>
+          </a:prstGeom>
+          <a:noFill/>
+        </p:spPr>
+        <p:txBody>
+          <a:bodyPr wrap="square">
+            <a:spAutoFit/>
+          </a:bodyPr>
+          <a:lstStyle/>
+          <a:p>
+            <a:pPr algn="l">
+              <a:defRPr sz="1100" b="0">
+                <a:solidFill>
+                  <a:srgbClr val="1E293B"/>
+                </a:solidFill>
+                <a:latin typeface="Malgun Gothic"/>
+              </a:defRPr>
+            </a:pPr>
+            <a:r>
+              <a:t>• M4: Phase 5 완료 (빌드/릴리스) - 2026-07-25</a:t>
+            </a:r>
+          </a:p>
+        </p:txBody>
+      </p:sp>
+      <p:sp>
+        <p:nvSpPr>
+          <p:cNvPr id="10" name="TextBox 9"/>
+          <p:cNvSpPr txBox="1"/>
+          <p:nvPr/>
+        </p:nvSpPr>
+        <p:spPr>
+          <a:xfrm>
+            <a:off x="457200" y="2468880"/>
+            <a:ext cx="4114800" cy="320040"/>
+          </a:xfrm>
+          <a:prstGeom prst="rect">
+            <a:avLst/>
+          </a:prstGeom>
+          <a:noFill/>
+        </p:spPr>
+        <p:txBody>
+          <a:bodyPr wrap="square">
+            <a:spAutoFit/>
+          </a:bodyPr>
+          <a:lstStyle/>
+          <a:p>
+            <a:pPr algn="l">
+              <a:defRPr sz="1100" b="0">
+                <a:solidFill>
+                  <a:srgbClr val="1E293B"/>
+                </a:solidFill>
+                <a:latin typeface="Malgun Gothic"/>
+              </a:defRPr>
+            </a:pPr>
+            <a:r>
+              <a:t>• M5: 스토어 배포 - 2026-08-05</a:t>
+            </a:r>
+          </a:p>
+        </p:txBody>
+      </p:sp>
+      <p:sp>
+        <p:nvSpPr>
+          <p:cNvPr id="11" name="TextBox 10"/>
+          <p:cNvSpPr txBox="1"/>
+          <p:nvPr/>
+        </p:nvSpPr>
+        <p:spPr>
+          <a:xfrm>
+            <a:off x="4754880" y="822960"/>
+            <a:ext cx="4114800" cy="365760"/>
+          </a:xfrm>
+          <a:prstGeom prst="rect">
+            <a:avLst/>
+          </a:prstGeom>
+          <a:noFill/>
+        </p:spPr>
+        <p:txBody>
+          <a:bodyPr wrap="square">
+            <a:spAutoFit/>
+          </a:bodyPr>
+          <a:lstStyle/>
+          <a:p>
+            <a:pPr algn="l">
+              <a:defRPr sz="1400" b="1">
+                <a:solidFill>
+                  <a:srgbClr val="0D9488"/>
+                </a:solidFill>
+                <a:latin typeface="Malgun Gothic"/>
+              </a:defRPr>
+            </a:pPr>
+            <a:r>
+              <a:t>간트 차트 (Phase별)</a:t>
+            </a:r>
+          </a:p>
+        </p:txBody>
+      </p:sp>
+      <p:sp>
+        <p:nvSpPr>
+          <p:cNvPr id="12" name="TextBox 11"/>
+          <p:cNvSpPr txBox="1"/>
+          <p:nvPr/>
+        </p:nvSpPr>
+        <p:spPr>
+          <a:xfrm>
+            <a:off x="4754880" y="1143000"/>
+            <a:ext cx="4114800" cy="274320"/>
+          </a:xfrm>
+          <a:prstGeom prst="rect">
+            <a:avLst/>
+          </a:prstGeom>
+          <a:noFill/>
+        </p:spPr>
+        <p:txBody>
+          <a:bodyPr wrap="square">
+            <a:spAutoFit/>
+          </a:bodyPr>
+          <a:lstStyle/>
+          <a:p>
+            <a:pPr algn="l">
+              <a:defRPr sz="900" b="0">
+                <a:solidFill>
+                  <a:srgbClr val="1E293B"/>
+                </a:solidFill>
+                <a:latin typeface="Malgun Gothic"/>
+              </a:defRPr>
+            </a:pPr>
+            <a:r>
+              <a:t>6월 말   7월 초   7월 중   7월 말   8월</a:t>
+            </a:r>
+          </a:p>
+        </p:txBody>
+      </p:sp>
+      <p:sp>
+        <p:nvSpPr>
+          <p:cNvPr id="13" name="Rectangle 12"/>
           <p:cNvSpPr/>
           <p:nvPr/>
         </p:nvSpPr>
         <p:spPr>
           <a:xfrm>
-            <a:off x="457200" y="960120"/>
-            <a:ext cx="137160" cy="137160"/>
-          </a:xfrm>
-          <a:prstGeom prst="ellipse">
+            <a:off x="4754880" y="1554480"/>
+            <a:ext cx="4114800" cy="320040"/>
+          </a:xfrm>
+          <a:prstGeom prst="rect">
             <a:avLst/>
           </a:prstGeom>
           <a:solidFill>
@@ -6209,14 +6942,14 @@
       </p:sp>
       <p:sp>
         <p:nvSpPr>
-          <p:cNvPr id="6" name="TextBox 5"/>
+          <p:cNvPr id="14" name="TextBox 13"/>
           <p:cNvSpPr txBox="1"/>
           <p:nvPr/>
         </p:nvSpPr>
         <p:spPr>
           <a:xfrm>
-            <a:off x="731520" y="914400"/>
-            <a:ext cx="7955279" cy="411480"/>
+            <a:off x="4800600" y="1600200"/>
+            <a:ext cx="4023360" cy="228600"/>
           </a:xfrm>
           <a:prstGeom prst="rect">
             <a:avLst/>
@@ -6230,35 +6963,35 @@
           <a:lstStyle/>
           <a:p>
             <a:pPr algn="l">
-              <a:defRPr sz="1300" b="0">
-                <a:solidFill>
-                  <a:srgbClr val="1E293B"/>
+              <a:defRPr sz="900" b="1">
+                <a:solidFill>
+                  <a:srgbClr val="FFFFFF"/>
                 </a:solidFill>
                 <a:latin typeface="Malgun Gothic"/>
               </a:defRPr>
             </a:pPr>
             <a:r>
-              <a:t>성경 데이터 모델 정의 (BibleBook, Chapter, Verse, VerseRef)</a:t>
-            </a:r>
-          </a:p>
-        </p:txBody>
-      </p:sp>
-      <p:sp>
-        <p:nvSpPr>
-          <p:cNvPr id="7" name="Oval 6"/>
+              <a:t>P0-2</a:t>
+            </a:r>
+          </a:p>
+        </p:txBody>
+      </p:sp>
+      <p:sp>
+        <p:nvSpPr>
+          <p:cNvPr id="15" name="Rectangle 14"/>
           <p:cNvSpPr/>
           <p:nvPr/>
         </p:nvSpPr>
         <p:spPr>
           <a:xfrm>
-            <a:off x="457200" y="1399032"/>
-            <a:ext cx="137160" cy="137160"/>
-          </a:xfrm>
-          <a:prstGeom prst="ellipse">
+            <a:off x="8869680" y="1965960"/>
+            <a:ext cx="2468880" cy="320040"/>
+          </a:xfrm>
+          <a:prstGeom prst="rect">
             <a:avLst/>
           </a:prstGeom>
           <a:solidFill>
-            <a:srgbClr val="0D9488"/>
+            <a:srgbClr val="D97706"/>
           </a:solidFill>
           <a:ln>
             <a:noFill/>
@@ -6288,14 +7021,14 @@
       </p:sp>
       <p:sp>
         <p:nvSpPr>
-          <p:cNvPr id="8" name="TextBox 7"/>
+          <p:cNvPr id="16" name="TextBox 15"/>
           <p:cNvSpPr txBox="1"/>
           <p:nvPr/>
         </p:nvSpPr>
         <p:spPr>
           <a:xfrm>
-            <a:off x="731520" y="1353312"/>
-            <a:ext cx="7955279" cy="411480"/>
+            <a:off x="8915400" y="2011679"/>
+            <a:ext cx="2377440" cy="228600"/>
           </a:xfrm>
           <a:prstGeom prst="rect">
             <a:avLst/>
@@ -6309,35 +7042,35 @@
           <a:lstStyle/>
           <a:p>
             <a:pPr algn="l">
-              <a:defRPr sz="1300" b="0">
-                <a:solidFill>
-                  <a:srgbClr val="1E293B"/>
+              <a:defRPr sz="900" b="1">
+                <a:solidFill>
+                  <a:srgbClr val="FFFFFF"/>
                 </a:solidFill>
                 <a:latin typeface="Malgun Gothic"/>
               </a:defRPr>
             </a:pPr>
             <a:r>
-              <a:t>Hive 어댑터 생성 (@HiveType, @HiveField)</a:t>
-            </a:r>
-          </a:p>
-        </p:txBody>
-      </p:sp>
-      <p:sp>
-        <p:nvSpPr>
-          <p:cNvPr id="9" name="Oval 8"/>
+              <a:t>P3</a:t>
+            </a:r>
+          </a:p>
+        </p:txBody>
+      </p:sp>
+      <p:sp>
+        <p:nvSpPr>
+          <p:cNvPr id="17" name="Rectangle 16"/>
           <p:cNvSpPr/>
           <p:nvPr/>
         </p:nvSpPr>
         <p:spPr>
           <a:xfrm>
-            <a:off x="457200" y="1837943"/>
-            <a:ext cx="137160" cy="137160"/>
-          </a:xfrm>
-          <a:prstGeom prst="ellipse">
+            <a:off x="11338560" y="2377440"/>
+            <a:ext cx="2057400" cy="320040"/>
+          </a:xfrm>
+          <a:prstGeom prst="rect">
             <a:avLst/>
           </a:prstGeom>
           <a:solidFill>
-            <a:srgbClr val="0D9488"/>
+            <a:srgbClr val="D97706"/>
           </a:solidFill>
           <a:ln>
             <a:noFill/>
@@ -6367,14 +7100,14 @@
       </p:sp>
       <p:sp>
         <p:nvSpPr>
-          <p:cNvPr id="10" name="TextBox 9"/>
+          <p:cNvPr id="18" name="TextBox 17"/>
           <p:cNvSpPr txBox="1"/>
           <p:nvPr/>
         </p:nvSpPr>
         <p:spPr>
           <a:xfrm>
-            <a:off x="731520" y="1792224"/>
-            <a:ext cx="7955279" cy="411480"/>
+            <a:off x="11384280" y="2423160"/>
+            <a:ext cx="1965960" cy="228600"/>
           </a:xfrm>
           <a:prstGeom prst="rect">
             <a:avLst/>
@@ -6388,35 +7121,35 @@
           <a:lstStyle/>
           <a:p>
             <a:pPr algn="l">
-              <a:defRPr sz="1300" b="0">
-                <a:solidFill>
-                  <a:srgbClr val="1E293B"/>
+              <a:defRPr sz="900" b="1">
+                <a:solidFill>
+                  <a:srgbClr val="FFFFFF"/>
                 </a:solidFill>
                 <a:latin typeface="Malgun Gothic"/>
               </a:defRPr>
             </a:pPr>
             <a:r>
-              <a:t>build_runner 실행으로 어댑터 코드 생성</a:t>
-            </a:r>
-          </a:p>
-        </p:txBody>
-      </p:sp>
-      <p:sp>
-        <p:nvSpPr>
-          <p:cNvPr id="11" name="Oval 10"/>
+              <a:t>P4</a:t>
+            </a:r>
+          </a:p>
+        </p:txBody>
+      </p:sp>
+      <p:sp>
+        <p:nvSpPr>
+          <p:cNvPr id="19" name="Rectangle 18"/>
           <p:cNvSpPr/>
           <p:nvPr/>
         </p:nvSpPr>
         <p:spPr>
           <a:xfrm>
-            <a:off x="457200" y="2276856"/>
-            <a:ext cx="137160" cy="137160"/>
-          </a:xfrm>
-          <a:prstGeom prst="ellipse">
+            <a:off x="13395960" y="2788920"/>
+            <a:ext cx="1645920" cy="320040"/>
+          </a:xfrm>
+          <a:prstGeom prst="rect">
             <a:avLst/>
           </a:prstGeom>
           <a:solidFill>
-            <a:srgbClr val="0D9488"/>
+            <a:srgbClr val="D97706"/>
           </a:solidFill>
           <a:ln>
             <a:noFill/>
@@ -6446,14 +7179,14 @@
       </p:sp>
       <p:sp>
         <p:nvSpPr>
-          <p:cNvPr id="12" name="TextBox 11"/>
+          <p:cNvPr id="20" name="TextBox 19"/>
           <p:cNvSpPr txBox="1"/>
           <p:nvPr/>
         </p:nvSpPr>
         <p:spPr>
           <a:xfrm>
-            <a:off x="731520" y="2231136"/>
-            <a:ext cx="7955279" cy="411480"/>
+            <a:off x="13441680" y="2834640"/>
+            <a:ext cx="1554480" cy="228600"/>
           </a:xfrm>
           <a:prstGeom prst="rect">
             <a:avLst/>
@@ -6467,72 +7200,29 @@
           <a:lstStyle/>
           <a:p>
             <a:pPr algn="l">
-              <a:defRPr sz="1300" b="0">
-                <a:solidFill>
-                  <a:srgbClr val="1E293B"/>
+              <a:defRPr sz="900" b="1">
+                <a:solidFill>
+                  <a:srgbClr val="FFFFFF"/>
                 </a:solidFill>
                 <a:latin typeface="Malgun Gothic"/>
               </a:defRPr>
             </a:pPr>
             <a:r>
-              <a:t>JSON 파서 서비스 구현 (rootBundle 사용)</a:t>
-            </a:r>
-          </a:p>
-        </p:txBody>
-      </p:sp>
-      <p:sp>
-        <p:nvSpPr>
-          <p:cNvPr id="13" name="Oval 12"/>
-          <p:cNvSpPr/>
-          <p:nvPr/>
-        </p:nvSpPr>
-        <p:spPr>
-          <a:xfrm>
-            <a:off x="457200" y="2715768"/>
-            <a:ext cx="137160" cy="137160"/>
-          </a:xfrm>
-          <a:prstGeom prst="ellipse">
-            <a:avLst/>
-          </a:prstGeom>
-          <a:solidFill>
-            <a:srgbClr val="0D9488"/>
-          </a:solidFill>
-          <a:ln>
-            <a:noFill/>
-          </a:ln>
-        </p:spPr>
-        <p:style>
-          <a:lnRef idx="1">
-            <a:schemeClr val="accent1"/>
-          </a:lnRef>
-          <a:fillRef idx="3">
-            <a:schemeClr val="accent1"/>
-          </a:fillRef>
-          <a:effectRef idx="2">
-            <a:schemeClr val="accent1"/>
-          </a:effectRef>
-          <a:fontRef idx="minor">
-            <a:schemeClr val="lt1"/>
-          </a:fontRef>
-        </p:style>
-        <p:txBody>
-          <a:bodyPr rtlCol="0" anchor="ctr"/>
-          <a:lstStyle/>
-          <a:p>
-            <a:pPr algn="ctr"/>
-          </a:p>
-        </p:txBody>
-      </p:sp>
-      <p:sp>
-        <p:nvSpPr>
-          <p:cNvPr id="14" name="TextBox 13"/>
+              <a:t>P5</a:t>
+            </a:r>
+          </a:p>
+        </p:txBody>
+      </p:sp>
+      <p:sp>
+        <p:nvSpPr>
+          <p:cNvPr id="21" name="TextBox 20"/>
           <p:cNvSpPr txBox="1"/>
           <p:nvPr/>
         </p:nvSpPr>
         <p:spPr>
           <a:xfrm>
-            <a:off x="731520" y="2670048"/>
-            <a:ext cx="7955279" cy="411480"/>
+            <a:off x="457200" y="4114800"/>
+            <a:ext cx="8229600" cy="731520"/>
           </a:xfrm>
           <a:prstGeom prst="rect">
             <a:avLst/>
@@ -6546,7 +7236,7 @@
           <a:lstStyle/>
           <a:p>
             <a:pPr algn="l">
-              <a:defRPr sz="1300" b="0">
+              <a:defRPr sz="1100" b="0">
                 <a:solidFill>
                   <a:srgbClr val="1E293B"/>
                 </a:solidFill>
@@ -6554,86 +7244,7 @@
               </a:defRPr>
             </a:pPr>
             <a:r>
-              <a:t>앱 시작 시 데이터 로드 + Hive Box 시드</a:t>
-            </a:r>
-          </a:p>
-        </p:txBody>
-      </p:sp>
-      <p:sp>
-        <p:nvSpPr>
-          <p:cNvPr id="15" name="Oval 14"/>
-          <p:cNvSpPr/>
-          <p:nvPr/>
-        </p:nvSpPr>
-        <p:spPr>
-          <a:xfrm>
-            <a:off x="457200" y="3154679"/>
-            <a:ext cx="137160" cy="137160"/>
-          </a:xfrm>
-          <a:prstGeom prst="ellipse">
-            <a:avLst/>
-          </a:prstGeom>
-          <a:solidFill>
-            <a:srgbClr val="0D9488"/>
-          </a:solidFill>
-          <a:ln>
-            <a:noFill/>
-          </a:ln>
-        </p:spPr>
-        <p:style>
-          <a:lnRef idx="1">
-            <a:schemeClr val="accent1"/>
-          </a:lnRef>
-          <a:fillRef idx="3">
-            <a:schemeClr val="accent1"/>
-          </a:fillRef>
-          <a:effectRef idx="2">
-            <a:schemeClr val="accent1"/>
-          </a:effectRef>
-          <a:fontRef idx="minor">
-            <a:schemeClr val="lt1"/>
-          </a:fontRef>
-        </p:style>
-        <p:txBody>
-          <a:bodyPr rtlCol="0" anchor="ctr"/>
-          <a:lstStyle/>
-          <a:p>
-            <a:pPr algn="ctr"/>
-          </a:p>
-        </p:txBody>
-      </p:sp>
-      <p:sp>
-        <p:nvSpPr>
-          <p:cNvPr id="16" name="TextBox 15"/>
-          <p:cNvSpPr txBox="1"/>
-          <p:nvPr/>
-        </p:nvSpPr>
-        <p:spPr>
-          <a:xfrm>
-            <a:off x="731520" y="3108960"/>
-            <a:ext cx="7955279" cy="411480"/>
-          </a:xfrm>
-          <a:prstGeom prst="rect">
-            <a:avLst/>
-          </a:prstGeom>
-          <a:noFill/>
-        </p:spPr>
-        <p:txBody>
-          <a:bodyPr wrap="square">
-            <a:spAutoFit/>
-          </a:bodyPr>
-          <a:lstStyle/>
-          <a:p>
-            <a:pPr algn="l">
-              <a:defRPr sz="1300" b="0">
-                <a:solidFill>
-                  <a:srgbClr val="1E293B"/>
-                </a:solidFill>
-                <a:latin typeface="Malgun Gothic"/>
-              </a:defRPr>
-            </a:pPr>
-            <a:r>
-              <a:t>데이터 검증 및 로딩 성능 측정</a:t>
+              <a:t>✅ = 완료   |   Gantt 바: Phase 기간 (주 단위 추정)   |   상세 일정은 백로그 MD 참조</a:t>
             </a:r>
           </a:p>
         </p:txBody>
@@ -6773,7 +7384,7 @@
               </a:defRPr>
             </a:pPr>
             <a:r>
-              <a:t>Phase 2: 핵심 읽기 MVP</a:t>
+              <a:t>Phase 1: 데이터 계층 (최우선)</a:t>
             </a:r>
           </a:p>
         </p:txBody>
@@ -6852,7 +7463,7 @@
               </a:defRPr>
             </a:pPr>
             <a:r>
-              <a:t>책 목록 화면 (구약/신약 분류)</a:t>
+              <a:t>성경 데이터 모델 정의 (BibleBook, Chapter, Verse, VerseRef)</a:t>
             </a:r>
           </a:p>
         </p:txBody>
@@ -6931,7 +7542,7 @@
               </a:defRPr>
             </a:pPr>
             <a:r>
-              <a:t>장 선택 화면 (그리드 또는 목록)</a:t>
+              <a:t>Hive 어댑터 생성 (@HiveType, @HiveField)</a:t>
             </a:r>
           </a:p>
         </p:txBody>
@@ -7010,7 +7621,7 @@
               </a:defRPr>
             </a:pPr>
             <a:r>
-              <a:t>본문 뷰어 (절 단위 표시, 스크롤)</a:t>
+              <a:t>build_runner 실행으로 어댑터 코드 생성</a:t>
             </a:r>
           </a:p>
         </p:txBody>
@@ -7089,7 +7700,7 @@
               </a:defRPr>
             </a:pPr>
             <a:r>
-              <a:t>이전/다음 장·책 네비게이션</a:t>
+              <a:t>JSON 파서 서비스 구현 (rootBundle 사용)</a:t>
             </a:r>
           </a:p>
         </p:txBody>
@@ -7168,7 +7779,7 @@
               </a:defRPr>
             </a:pPr>
             <a:r>
-              <a:t>현재 읽기 위치 저장 (Provider + 로컬)</a:t>
+              <a:t>앱 시작 시 데이터 로드 + Hive Box 시드</a:t>
             </a:r>
           </a:p>
         </p:txBody>
@@ -7247,7 +7858,7 @@
               </a:defRPr>
             </a:pPr>
             <a:r>
-              <a:t>하단 네비게이션 연결 (성경/북마크/검색)</a:t>
+              <a:t>데이터 검증 및 로딩 성능 측정</a:t>
             </a:r>
           </a:p>
         </p:txBody>
@@ -7328,7 +7939,7 @@
             <a:avLst/>
           </a:prstGeom>
           <a:solidFill>
-            <a:srgbClr val="D97706"/>
+            <a:srgbClr val="0D9488"/>
           </a:solidFill>
           <a:ln>
             <a:noFill/>
@@ -7387,7 +7998,7 @@
               </a:defRPr>
             </a:pPr>
             <a:r>
-              <a:t>Phase 3+: 사용자 기능 + 추가 콘텐츠</a:t>
+              <a:t>Phase 2: 핵심 읽기 MVP</a:t>
             </a:r>
           </a:p>
         </p:txBody>
@@ -7407,7 +8018,7 @@
             <a:avLst/>
           </a:prstGeom>
           <a:solidFill>
-            <a:srgbClr val="D97706"/>
+            <a:srgbClr val="0D9488"/>
           </a:solidFill>
           <a:ln>
             <a:noFill/>
@@ -7466,7 +8077,7 @@
               </a:defRPr>
             </a:pPr>
             <a:r>
-              <a:t>북마크 (Hive 저장, viewer 버튼)</a:t>
+              <a:t>책 목록 화면 (구약/신약 분류)</a:t>
             </a:r>
           </a:p>
         </p:txBody>
@@ -7486,7 +8097,7 @@
             <a:avLst/>
           </a:prstGeom>
           <a:solidFill>
-            <a:srgbClr val="D97706"/>
+            <a:srgbClr val="0D9488"/>
           </a:solidFill>
           <a:ln>
             <a:noFill/>
@@ -7545,7 +8156,7 @@
               </a:defRPr>
             </a:pPr>
             <a:r>
-              <a:t>설정 화면 (글꼴 크기, 테마, 다크모드)</a:t>
+              <a:t>장 선택 화면 (그리드 또는 목록)</a:t>
             </a:r>
           </a:p>
         </p:txBody>
@@ -7565,7 +8176,7 @@
             <a:avLst/>
           </a:prstGeom>
           <a:solidFill>
-            <a:srgbClr val="D97706"/>
+            <a:srgbClr val="0D9488"/>
           </a:solidFill>
           <a:ln>
             <a:noFill/>
@@ -7624,7 +8235,7 @@
               </a:defRPr>
             </a:pPr>
             <a:r>
-              <a:t>본문 검색 결과 polish</a:t>
+              <a:t>본문 뷰어 (절 단위 표시, 스크롤)</a:t>
             </a:r>
           </a:p>
         </p:txBody>
@@ -7644,7 +8255,7 @@
             <a:avLst/>
           </a:prstGeom>
           <a:solidFill>
-            <a:srgbClr val="D97706"/>
+            <a:srgbClr val="0D9488"/>
           </a:solidFill>
           <a:ln>
             <a:noFill/>
@@ -7703,7 +8314,7 @@
               </a:defRPr>
             </a:pPr>
             <a:r>
-              <a:t>찬송가 가사 및 악보 보기</a:t>
+              <a:t>이전/다음 장·책 네비게이션</a:t>
             </a:r>
           </a:p>
         </p:txBody>
@@ -7723,7 +8334,7 @@
             <a:avLst/>
           </a:prstGeom>
           <a:solidFill>
-            <a:srgbClr val="D97706"/>
+            <a:srgbClr val="0D9488"/>
           </a:solidFill>
           <a:ln>
             <a:noFill/>
@@ -7782,7 +8393,7 @@
               </a:defRPr>
             </a:pPr>
             <a:r>
-              <a:t>사도신경, 주기도문, 교독문</a:t>
+              <a:t>현재 읽기 위치 저장 (Provider + 로컬)</a:t>
             </a:r>
           </a:p>
         </p:txBody>
@@ -7802,7 +8413,7 @@
             <a:avLst/>
           </a:prstGeom>
           <a:solidFill>
-            <a:srgbClr val="D97706"/>
+            <a:srgbClr val="0D9488"/>
           </a:solidFill>
           <a:ln>
             <a:noFill/>
@@ -7861,7 +8472,7 @@
               </a:defRPr>
             </a:pPr>
             <a:r>
-              <a:t>이 성경앱에 대해서 페이지</a:t>
+              <a:t>하단 네비게이션 연결 (성경/북마크/검색)</a:t>
             </a:r>
           </a:p>
         </p:txBody>
@@ -7979,7 +8590,7 @@
         <p:spPr>
           <a:xfrm>
             <a:off x="457200" y="228600"/>
-            <a:ext cx="8229600" cy="457200"/>
+            <a:ext cx="8229600" cy="548640"/>
           </a:xfrm>
           <a:prstGeom prst="rect">
             <a:avLst/>
@@ -8001,32 +8612,30 @@
               </a:defRPr>
             </a:pPr>
             <a:r>
-              <a:t>우선순위 작업 순서 (요약)</a:t>
-            </a:r>
-          </a:p>
-        </p:txBody>
-      </p:sp>
-      <p:sp>
-        <p:nvSpPr>
-          <p:cNvPr id="5" name="Rounded Rectangle 4"/>
+              <a:t>Phase 3+: 사용자 기능 + 추가 콘텐츠</a:t>
+            </a:r>
+          </a:p>
+        </p:txBody>
+      </p:sp>
+      <p:sp>
+        <p:nvSpPr>
+          <p:cNvPr id="5" name="Oval 4"/>
           <p:cNvSpPr/>
           <p:nvPr/>
         </p:nvSpPr>
         <p:spPr>
           <a:xfrm>
-            <a:off x="457200" y="868680"/>
-            <a:ext cx="8229600" cy="384048"/>
-          </a:xfrm>
-          <a:prstGeom prst="roundRect">
+            <a:off x="457200" y="960120"/>
+            <a:ext cx="137160" cy="137160"/>
+          </a:xfrm>
+          <a:prstGeom prst="ellipse">
             <a:avLst/>
           </a:prstGeom>
           <a:solidFill>
-            <a:srgbClr val="FFFFFF"/>
+            <a:srgbClr val="D97706"/>
           </a:solidFill>
           <a:ln>
-            <a:solidFill>
-              <a:srgbClr val="E2E8F0"/>
-            </a:solidFill>
+            <a:noFill/>
           </a:ln>
         </p:spPr>
         <p:style>
@@ -8059,8 +8668,8 @@
         </p:nvSpPr>
         <p:spPr>
           <a:xfrm>
-            <a:off x="640080" y="914400"/>
-            <a:ext cx="7863840" cy="320040"/>
+            <a:off x="731520" y="914400"/>
+            <a:ext cx="7955279" cy="411480"/>
           </a:xfrm>
           <a:prstGeom prst="rect">
             <a:avLst/>
@@ -8074,7 +8683,7 @@
           <a:lstStyle/>
           <a:p>
             <a:pPr algn="l">
-              <a:defRPr sz="1200" b="0">
+              <a:defRPr sz="1300" b="0">
                 <a:solidFill>
                   <a:srgbClr val="1E293B"/>
                 </a:solidFill>
@@ -8082,32 +8691,30 @@
               </a:defRPr>
             </a:pPr>
             <a:r>
-              <a:t>1. Phase 3 Day1~2: Bookmark model + Hive box + viewer 버튼 + 목록 (북마크)</a:t>
-            </a:r>
-          </a:p>
-        </p:txBody>
-      </p:sp>
-      <p:sp>
-        <p:nvSpPr>
-          <p:cNvPr id="7" name="Rounded Rectangle 6"/>
+              <a:t>북마크 (Hive 저장, viewer 버튼)</a:t>
+            </a:r>
+          </a:p>
+        </p:txBody>
+      </p:sp>
+      <p:sp>
+        <p:nvSpPr>
+          <p:cNvPr id="7" name="Oval 6"/>
           <p:cNvSpPr/>
           <p:nvPr/>
         </p:nvSpPr>
         <p:spPr>
           <a:xfrm>
-            <a:off x="457200" y="1325880"/>
-            <a:ext cx="8229600" cy="384048"/>
-          </a:xfrm>
-          <a:prstGeom prst="roundRect">
+            <a:off x="457200" y="1399032"/>
+            <a:ext cx="137160" cy="137160"/>
+          </a:xfrm>
+          <a:prstGeom prst="ellipse">
             <a:avLst/>
           </a:prstGeom>
           <a:solidFill>
-            <a:srgbClr val="FFFFFF"/>
+            <a:srgbClr val="D97706"/>
           </a:solidFill>
           <a:ln>
-            <a:solidFill>
-              <a:srgbClr val="E2E8F0"/>
-            </a:solidFill>
+            <a:noFill/>
           </a:ln>
         </p:spPr>
         <p:style>
@@ -8140,8 +8747,8 @@
         </p:nvSpPr>
         <p:spPr>
           <a:xfrm>
-            <a:off x="640080" y="1371600"/>
-            <a:ext cx="7863840" cy="320040"/>
+            <a:off x="731520" y="1353312"/>
+            <a:ext cx="7955279" cy="411480"/>
           </a:xfrm>
           <a:prstGeom prst="rect">
             <a:avLst/>
@@ -8155,7 +8762,7 @@
           <a:lstStyle/>
           <a:p>
             <a:pPr algn="l">
-              <a:defRPr sz="1200" b="0">
+              <a:defRPr sz="1300" b="0">
                 <a:solidFill>
                   <a:srgbClr val="1E293B"/>
                 </a:solidFill>
@@ -8163,32 +8770,30 @@
               </a:defRPr>
             </a:pPr>
             <a:r>
-              <a:t>2. Phase 3 Day2~3: 설정 화면 + 검색 결과 polish (글꼴/다크)</a:t>
-            </a:r>
-          </a:p>
-        </p:txBody>
-      </p:sp>
-      <p:sp>
-        <p:nvSpPr>
-          <p:cNvPr id="9" name="Rounded Rectangle 8"/>
+              <a:t>설정 화면 (글꼴 크기, 테마, 다크모드)</a:t>
+            </a:r>
+          </a:p>
+        </p:txBody>
+      </p:sp>
+      <p:sp>
+        <p:nvSpPr>
+          <p:cNvPr id="9" name="Oval 8"/>
           <p:cNvSpPr/>
           <p:nvPr/>
         </p:nvSpPr>
         <p:spPr>
           <a:xfrm>
-            <a:off x="457200" y="1783080"/>
-            <a:ext cx="8229600" cy="384048"/>
-          </a:xfrm>
-          <a:prstGeom prst="roundRect">
+            <a:off x="457200" y="1837943"/>
+            <a:ext cx="137160" cy="137160"/>
+          </a:xfrm>
+          <a:prstGeom prst="ellipse">
             <a:avLst/>
           </a:prstGeom>
           <a:solidFill>
-            <a:srgbClr val="FFFFFF"/>
+            <a:srgbClr val="D97706"/>
           </a:solidFill>
           <a:ln>
-            <a:solidFill>
-              <a:srgbClr val="E2E8F0"/>
-            </a:solidFill>
+            <a:noFill/>
           </a:ln>
         </p:spPr>
         <p:style>
@@ -8221,8 +8826,8 @@
         </p:nvSpPr>
         <p:spPr>
           <a:xfrm>
-            <a:off x="640080" y="1828800"/>
-            <a:ext cx="7863840" cy="320040"/>
+            <a:off x="731520" y="1792224"/>
+            <a:ext cx="7955279" cy="411480"/>
           </a:xfrm>
           <a:prstGeom prst="rect">
             <a:avLst/>
@@ -8236,7 +8841,7 @@
           <a:lstStyle/>
           <a:p>
             <a:pPr algn="l">
-              <a:defRPr sz="1200" b="0">
+              <a:defRPr sz="1300" b="0">
                 <a:solidFill>
                   <a:srgbClr val="1E293B"/>
                 </a:solidFill>
@@ -8244,32 +8849,30 @@
               </a:defRPr>
             </a:pPr>
             <a:r>
-              <a:t>3. 찬송가 가사+악보, 사도신경, 주기도문, 교독문 + About 페이지 구현</a:t>
-            </a:r>
-          </a:p>
-        </p:txBody>
-      </p:sp>
-      <p:sp>
-        <p:nvSpPr>
-          <p:cNvPr id="11" name="Rounded Rectangle 10"/>
+              <a:t>본문 검색 결과 polish</a:t>
+            </a:r>
+          </a:p>
+        </p:txBody>
+      </p:sp>
+      <p:sp>
+        <p:nvSpPr>
+          <p:cNvPr id="11" name="Oval 10"/>
           <p:cNvSpPr/>
           <p:nvPr/>
         </p:nvSpPr>
         <p:spPr>
           <a:xfrm>
-            <a:off x="457200" y="2240280"/>
-            <a:ext cx="8229600" cy="384048"/>
-          </a:xfrm>
-          <a:prstGeom prst="roundRect">
+            <a:off x="457200" y="2276856"/>
+            <a:ext cx="137160" cy="137160"/>
+          </a:xfrm>
+          <a:prstGeom prst="ellipse">
             <a:avLst/>
           </a:prstGeom>
           <a:solidFill>
-            <a:srgbClr val="FFFFFF"/>
+            <a:srgbClr val="D97706"/>
           </a:solidFill>
           <a:ln>
-            <a:solidFill>
-              <a:srgbClr val="E2E8F0"/>
-            </a:solidFill>
+            <a:noFill/>
           </a:ln>
         </p:spPr>
         <p:style>
@@ -8302,8 +8905,8 @@
         </p:nvSpPr>
         <p:spPr>
           <a:xfrm>
-            <a:off x="640080" y="2286000"/>
-            <a:ext cx="7863840" cy="320040"/>
+            <a:off x="731520" y="2231136"/>
+            <a:ext cx="7955279" cy="411480"/>
           </a:xfrm>
           <a:prstGeom prst="rect">
             <a:avLst/>
@@ -8317,7 +8920,7 @@
           <a:lstStyle/>
           <a:p>
             <a:pPr algn="l">
-              <a:defRPr sz="1200" b="0">
+              <a:defRPr sz="1300" b="0">
                 <a:solidFill>
                   <a:srgbClr val="1E293B"/>
                 </a:solidFill>
@@ -8325,32 +8928,30 @@
               </a:defRPr>
             </a:pPr>
             <a:r>
-              <a:t>4. Phase 4 Day1: Theme provider + 다크모드</a:t>
-            </a:r>
-          </a:p>
-        </p:txBody>
-      </p:sp>
-      <p:sp>
-        <p:nvSpPr>
-          <p:cNvPr id="13" name="Rounded Rectangle 12"/>
+              <a:t>찬송가 가사 및 악보 보기</a:t>
+            </a:r>
+          </a:p>
+        </p:txBody>
+      </p:sp>
+      <p:sp>
+        <p:nvSpPr>
+          <p:cNvPr id="13" name="Oval 12"/>
           <p:cNvSpPr/>
           <p:nvPr/>
         </p:nvSpPr>
         <p:spPr>
           <a:xfrm>
-            <a:off x="457200" y="2697480"/>
-            <a:ext cx="8229600" cy="384048"/>
-          </a:xfrm>
-          <a:prstGeom prst="roundRect">
+            <a:off x="457200" y="2715768"/>
+            <a:ext cx="137160" cy="137160"/>
+          </a:xfrm>
+          <a:prstGeom prst="ellipse">
             <a:avLst/>
           </a:prstGeom>
           <a:solidFill>
-            <a:srgbClr val="FFFFFF"/>
+            <a:srgbClr val="D97706"/>
           </a:solidFill>
           <a:ln>
-            <a:solidFill>
-              <a:srgbClr val="E2E8F0"/>
-            </a:solidFill>
+            <a:noFill/>
           </a:ln>
         </p:spPr>
         <p:style>
@@ -8383,8 +8984,8 @@
         </p:nvSpPr>
         <p:spPr>
           <a:xfrm>
-            <a:off x="640080" y="2743200"/>
-            <a:ext cx="7863840" cy="320040"/>
+            <a:off x="731520" y="2670048"/>
+            <a:ext cx="7955279" cy="411480"/>
           </a:xfrm>
           <a:prstGeom prst="rect">
             <a:avLst/>
@@ -8398,7 +8999,7 @@
           <a:lstStyle/>
           <a:p>
             <a:pPr algn="l">
-              <a:defRPr sz="1200" b="0">
+              <a:defRPr sz="1300" b="0">
                 <a:solidFill>
                   <a:srgbClr val="1E293B"/>
                 </a:solidFill>
@@ -8406,32 +9007,30 @@
               </a:defRPr>
             </a:pPr>
             <a:r>
-              <a:t>5. Phase 4 Day3~5: 반응형 LayoutBuilder + 접근성</a:t>
-            </a:r>
-          </a:p>
-        </p:txBody>
-      </p:sp>
-      <p:sp>
-        <p:nvSpPr>
-          <p:cNvPr id="15" name="Rounded Rectangle 14"/>
+              <a:t>사도신경, 주기도문, 교독문</a:t>
+            </a:r>
+          </a:p>
+        </p:txBody>
+      </p:sp>
+      <p:sp>
+        <p:nvSpPr>
+          <p:cNvPr id="15" name="Oval 14"/>
           <p:cNvSpPr/>
           <p:nvPr/>
         </p:nvSpPr>
         <p:spPr>
           <a:xfrm>
-            <a:off x="457200" y="3154680"/>
-            <a:ext cx="8229600" cy="384048"/>
-          </a:xfrm>
-          <a:prstGeom prst="roundRect">
+            <a:off x="457200" y="3154679"/>
+            <a:ext cx="137160" cy="137160"/>
+          </a:xfrm>
+          <a:prstGeom prst="ellipse">
             <a:avLst/>
           </a:prstGeom>
           <a:solidFill>
-            <a:srgbClr val="FFFFFF"/>
+            <a:srgbClr val="D97706"/>
           </a:solidFill>
           <a:ln>
-            <a:solidFill>
-              <a:srgbClr val="E2E8F0"/>
-            </a:solidFill>
+            <a:noFill/>
           </a:ln>
         </p:spPr>
         <p:style>
@@ -8464,8 +9063,8 @@
         </p:nvSpPr>
         <p:spPr>
           <a:xfrm>
-            <a:off x="640080" y="3200400"/>
-            <a:ext cx="7863840" cy="320040"/>
+            <a:off x="731520" y="3108960"/>
+            <a:ext cx="7955279" cy="411480"/>
           </a:xfrm>
           <a:prstGeom prst="rect">
             <a:avLst/>
@@ -8479,7 +9078,7 @@
           <a:lstStyle/>
           <a:p>
             <a:pPr algn="l">
-              <a:defRPr sz="1200" b="0">
+              <a:defRPr sz="1300" b="0">
                 <a:solidFill>
                   <a:srgbClr val="1E293B"/>
                 </a:solidFill>
@@ -8487,205 +9086,7 @@
               </a:defRPr>
             </a:pPr>
             <a:r>
-              <a:t>6. Phase 5 Day1~2: Android build + 테스트</a:t>
-            </a:r>
-          </a:p>
-        </p:txBody>
-      </p:sp>
-      <p:sp>
-        <p:nvSpPr>
-          <p:cNvPr id="17" name="Rounded Rectangle 16"/>
-          <p:cNvSpPr/>
-          <p:nvPr/>
-        </p:nvSpPr>
-        <p:spPr>
-          <a:xfrm>
-            <a:off x="457200" y="3611880"/>
-            <a:ext cx="8229600" cy="384048"/>
-          </a:xfrm>
-          <a:prstGeom prst="roundRect">
-            <a:avLst/>
-          </a:prstGeom>
-          <a:solidFill>
-            <a:srgbClr val="FFFFFF"/>
-          </a:solidFill>
-          <a:ln>
-            <a:solidFill>
-              <a:srgbClr val="E2E8F0"/>
-            </a:solidFill>
-          </a:ln>
-        </p:spPr>
-        <p:style>
-          <a:lnRef idx="1">
-            <a:schemeClr val="accent1"/>
-          </a:lnRef>
-          <a:fillRef idx="3">
-            <a:schemeClr val="accent1"/>
-          </a:fillRef>
-          <a:effectRef idx="2">
-            <a:schemeClr val="accent1"/>
-          </a:effectRef>
-          <a:fontRef idx="minor">
-            <a:schemeClr val="lt1"/>
-          </a:fontRef>
-        </p:style>
-        <p:txBody>
-          <a:bodyPr rtlCol="0" anchor="ctr"/>
-          <a:lstStyle/>
-          <a:p>
-            <a:pPr algn="ctr"/>
-          </a:p>
-        </p:txBody>
-      </p:sp>
-      <p:sp>
-        <p:nvSpPr>
-          <p:cNvPr id="18" name="TextBox 17"/>
-          <p:cNvSpPr txBox="1"/>
-          <p:nvPr/>
-        </p:nvSpPr>
-        <p:spPr>
-          <a:xfrm>
-            <a:off x="640080" y="3657600"/>
-            <a:ext cx="7863840" cy="320040"/>
-          </a:xfrm>
-          <a:prstGeom prst="rect">
-            <a:avLst/>
-          </a:prstGeom>
-          <a:noFill/>
-        </p:spPr>
-        <p:txBody>
-          <a:bodyPr wrap="square">
-            <a:spAutoFit/>
-          </a:bodyPr>
-          <a:lstStyle/>
-          <a:p>
-            <a:pPr algn="l">
-              <a:defRPr sz="1200" b="0">
-                <a:solidFill>
-                  <a:srgbClr val="1E293B"/>
-                </a:solidFill>
-                <a:latin typeface="Malgun Gothic"/>
-              </a:defRPr>
-            </a:pPr>
-            <a:r>
-              <a:t>7. Phase 5 Day2~4: iOS build + Xcode 테스트</a:t>
-            </a:r>
-          </a:p>
-        </p:txBody>
-      </p:sp>
-      <p:sp>
-        <p:nvSpPr>
-          <p:cNvPr id="19" name="Rounded Rectangle 18"/>
-          <p:cNvSpPr/>
-          <p:nvPr/>
-        </p:nvSpPr>
-        <p:spPr>
-          <a:xfrm>
-            <a:off x="457200" y="4069080"/>
-            <a:ext cx="8229600" cy="384048"/>
-          </a:xfrm>
-          <a:prstGeom prst="roundRect">
-            <a:avLst/>
-          </a:prstGeom>
-          <a:solidFill>
-            <a:srgbClr val="FFFFFF"/>
-          </a:solidFill>
-          <a:ln>
-            <a:solidFill>
-              <a:srgbClr val="E2E8F0"/>
-            </a:solidFill>
-          </a:ln>
-        </p:spPr>
-        <p:style>
-          <a:lnRef idx="1">
-            <a:schemeClr val="accent1"/>
-          </a:lnRef>
-          <a:fillRef idx="3">
-            <a:schemeClr val="accent1"/>
-          </a:fillRef>
-          <a:effectRef idx="2">
-            <a:schemeClr val="accent1"/>
-          </a:effectRef>
-          <a:fontRef idx="minor">
-            <a:schemeClr val="lt1"/>
-          </a:fontRef>
-        </p:style>
-        <p:txBody>
-          <a:bodyPr rtlCol="0" anchor="ctr"/>
-          <a:lstStyle/>
-          <a:p>
-            <a:pPr algn="ctr"/>
-          </a:p>
-        </p:txBody>
-      </p:sp>
-      <p:sp>
-        <p:nvSpPr>
-          <p:cNvPr id="20" name="TextBox 19"/>
-          <p:cNvSpPr txBox="1"/>
-          <p:nvPr/>
-        </p:nvSpPr>
-        <p:spPr>
-          <a:xfrm>
-            <a:off x="640080" y="4114800"/>
-            <a:ext cx="7863840" cy="320040"/>
-          </a:xfrm>
-          <a:prstGeom prst="rect">
-            <a:avLst/>
-          </a:prstGeom>
-          <a:noFill/>
-        </p:spPr>
-        <p:txBody>
-          <a:bodyPr wrap="square">
-            <a:spAutoFit/>
-          </a:bodyPr>
-          <a:lstStyle/>
-          <a:p>
-            <a:pPr algn="l">
-              <a:defRPr sz="1200" b="0">
-                <a:solidFill>
-                  <a:srgbClr val="1E293B"/>
-                </a:solidFill>
-                <a:latin typeface="Malgun Gothic"/>
-              </a:defRPr>
-            </a:pPr>
-            <a:r>
-              <a:t>8. Phase 5 Day4~7: Web PWA + 릴리스 + 스토어 준비</a:t>
-            </a:r>
-          </a:p>
-        </p:txBody>
-      </p:sp>
-      <p:sp>
-        <p:nvSpPr>
-          <p:cNvPr id="21" name="TextBox 20"/>
-          <p:cNvSpPr txBox="1"/>
-          <p:nvPr/>
-        </p:nvSpPr>
-        <p:spPr>
-          <a:xfrm>
-            <a:off x="457200" y="4663440"/>
-            <a:ext cx="8229600" cy="365760"/>
-          </a:xfrm>
-          <a:prstGeom prst="rect">
-            <a:avLst/>
-          </a:prstGeom>
-          <a:noFill/>
-        </p:spPr>
-        <p:txBody>
-          <a:bodyPr wrap="square">
-            <a:spAutoFit/>
-          </a:bodyPr>
-          <a:lstStyle/>
-          <a:p>
-            <a:pPr algn="l">
-              <a:defRPr sz="1000" b="0">
-                <a:solidFill>
-                  <a:srgbClr val="64748B"/>
-                </a:solidFill>
-                <a:latin typeface="Malgun Gothic"/>
-              </a:defRPr>
-            </a:pPr>
-            <a:r>
-              <a:t>상세 백로그: docs/Task_Prioritized_Backlog_and_Schedule_2026-06-19.md 참조</a:t>
+              <a:t>이 성경앱에 대해서 페이지</a:t>
             </a:r>
           </a:p>
         </p:txBody>

</xml_diff>